<commit_message>
fix: render categorical tag in layered arch band; correct plan EMU
Co-Authored-By: Claude Opus 4.8 <noreply@anthropic.com>
</commit_message>
<xml_diff>
--- a/dist/slide-style.pptx
+++ b/dist/slide-style.pptx
@@ -3456,7 +3456,42 @@
       </p:sp>
       <p:sp>
         <p:nvSpPr>
-          <p:cNvPr id="5" name="Rounded Rectangle 4"/>
+          <p:cNvPr id="5" name="TextBox 4"/>
+          <p:cNvSpPr txBox="1"/>
+          <p:nvPr/>
+        </p:nvSpPr>
+        <p:spPr>
+          <a:xfrm>
+            <a:off x="9326880" y="2560320"/>
+            <a:ext cx="1828800" cy="960120"/>
+          </a:xfrm>
+          <a:prstGeom prst="rect">
+            <a:avLst/>
+          </a:prstGeom>
+          <a:noFill/>
+        </p:spPr>
+        <p:txBody>
+          <a:bodyPr wrap="none" anchor="ctr">
+            <a:spAutoFit/>
+          </a:bodyPr>
+          <a:lstStyle/>
+          <a:p>
+            <a:pPr algn="r"/>
+            <a:r>
+              <a:rPr sz="1100" b="1" spc="170">
+                <a:solidFill>
+                  <a:srgbClr val="C2410C"/>
+                </a:solidFill>
+                <a:latin typeface="Helvetica Neue"/>
+              </a:rPr>
+              <a:t>SERVE</a:t>
+            </a:r>
+          </a:p>
+        </p:txBody>
+      </p:sp>
+      <p:sp>
+        <p:nvSpPr>
+          <p:cNvPr id="6" name="Rounded Rectangle 5"/>
           <p:cNvSpPr/>
           <p:nvPr/>
         </p:nvSpPr>
@@ -3512,7 +3547,42 @@
       </p:sp>
       <p:sp>
         <p:nvSpPr>
-          <p:cNvPr id="6" name="Rounded Rectangle 5"/>
+          <p:cNvPr id="7" name="TextBox 6"/>
+          <p:cNvSpPr txBox="1"/>
+          <p:nvPr/>
+        </p:nvSpPr>
+        <p:spPr>
+          <a:xfrm>
+            <a:off x="9326880" y="3703320"/>
+            <a:ext cx="1828800" cy="960120"/>
+          </a:xfrm>
+          <a:prstGeom prst="rect">
+            <a:avLst/>
+          </a:prstGeom>
+          <a:noFill/>
+        </p:spPr>
+        <p:txBody>
+          <a:bodyPr wrap="none" anchor="ctr">
+            <a:spAutoFit/>
+          </a:bodyPr>
+          <a:lstStyle/>
+          <a:p>
+            <a:pPr algn="r"/>
+            <a:r>
+              <a:rPr sz="1100" b="1" spc="170">
+                <a:solidFill>
+                  <a:srgbClr val="0A6E6F"/>
+                </a:solidFill>
+                <a:latin typeface="Helvetica Neue"/>
+              </a:rPr>
+              <a:t>PROCESS</a:t>
+            </a:r>
+          </a:p>
+        </p:txBody>
+      </p:sp>
+      <p:sp>
+        <p:nvSpPr>
+          <p:cNvPr id="8" name="Rounded Rectangle 7"/>
           <p:cNvSpPr/>
           <p:nvPr/>
         </p:nvSpPr>
@@ -3568,7 +3638,42 @@
       </p:sp>
       <p:sp>
         <p:nvSpPr>
-          <p:cNvPr id="7" name="TextBox 6"/>
+          <p:cNvPr id="9" name="TextBox 8"/>
+          <p:cNvSpPr txBox="1"/>
+          <p:nvPr/>
+        </p:nvSpPr>
+        <p:spPr>
+          <a:xfrm>
+            <a:off x="9326880" y="4846320"/>
+            <a:ext cx="1828800" cy="960120"/>
+          </a:xfrm>
+          <a:prstGeom prst="rect">
+            <a:avLst/>
+          </a:prstGeom>
+          <a:noFill/>
+        </p:spPr>
+        <p:txBody>
+          <a:bodyPr wrap="none" anchor="ctr">
+            <a:spAutoFit/>
+          </a:bodyPr>
+          <a:lstStyle/>
+          <a:p>
+            <a:pPr algn="r"/>
+            <a:r>
+              <a:rPr sz="1100" b="1" spc="170">
+                <a:solidFill>
+                  <a:srgbClr val="1D4ED8"/>
+                </a:solidFill>
+                <a:latin typeface="Helvetica Neue"/>
+              </a:rPr>
+              <a:t>INGEST</a:t>
+            </a:r>
+          </a:p>
+        </p:txBody>
+      </p:sp>
+      <p:sp>
+        <p:nvSpPr>
+          <p:cNvPr id="10" name="TextBox 9"/>
           <p:cNvSpPr txBox="1"/>
           <p:nvPr/>
         </p:nvSpPr>

</xml_diff>

<commit_message>
feat: add swim-lane architecture example (Pattern D)
Layout-rich MLOps-style lifecycle: environment swim-lanes with rotated labels,
a shared data-store cylinder straddling the divider, titled subsystem containers
(warm Dev / cool Prod), horizontal flow with a hyperparameter feedback arc,
decision diamond + retrain loop, document artifacts, and labeled cross-lane
connectors. Echoes a hand-made reference; restyled to the Apple-minimal palette.

Adds shape-kit primitives: container, cylinder, document, diamond, lane_label,
feedback_arc, connector_labeled. Gallery now 15 slides.

Co-Authored-By: Claude Opus 4.8 <noreply@anthropic.com>
</commit_message>
<xml_diff>
--- a/dist/slide-style.pptx
+++ b/dist/slide-style.pptx
@@ -19,6 +19,7 @@
     <p:sldId id="267" r:id="rId18"/>
     <p:sldId id="268" r:id="rId19"/>
     <p:sldId id="269" r:id="rId20"/>
+    <p:sldId id="270" r:id="rId21"/>
   </p:sldIdLst>
   <p:sldSz cx="12192000" cy="6858000" type="screen4x3"/>
   <p:notesSz cx="6858000" cy="9144000"/>
@@ -4125,7 +4126,7 @@
         </p:nvSpPr>
         <p:spPr>
           <a:xfrm>
-            <a:off x="822960" y="822960"/>
+            <a:off x="822960" y="384048"/>
             <a:ext cx="5486400" cy="365760"/>
           </a:xfrm>
           <a:prstGeom prst="rect">
@@ -4151,7 +4152,7 @@
                 </a:solidFill>
                 <a:latin typeface="Helvetica Neue"/>
               </a:rPr>
-              <a:t>VISUAL</a:t>
+              <a:t>ARCHITECTURE</a:t>
             </a:r>
           </a:p>
         </p:txBody>
@@ -4164,8 +4165,8 @@
         </p:nvSpPr>
         <p:spPr>
           <a:xfrm>
-            <a:off x="786384" y="1234440"/>
-            <a:ext cx="5486400" cy="1463040"/>
+            <a:off x="786384" y="731520"/>
+            <a:ext cx="10972800" cy="640080"/>
           </a:xfrm>
           <a:prstGeom prst="rect">
             <a:avLst/>
@@ -4184,32 +4185,229 @@
               </a:lnSpc>
             </a:pPr>
             <a:r>
-              <a:rPr sz="3400" b="1" spc="-40">
+              <a:rPr sz="2400" b="1" spc="-40">
                 <a:solidFill>
                   <a:srgbClr val="1D1D1F"/>
                 </a:solidFill>
                 <a:latin typeface="Helvetica Neue"/>
               </a:rPr>
-              <a:t>Image + caption</a:t>
-            </a:r>
-          </a:p>
-        </p:txBody>
-      </p:sp>
-      <p:sp>
-        <p:nvSpPr>
-          <p:cNvPr id="4" name="Rounded Rectangle 3"/>
+              <a:t>ML lifecycle across environments</a:t>
+            </a:r>
+          </a:p>
+        </p:txBody>
+      </p:sp>
+      <p:cxnSp>
+        <p:nvCxnSpPr>
+          <p:cNvPr id="4" name="Connector 3"/>
+          <p:cNvCxnSpPr/>
+          <p:nvPr/>
+        </p:nvCxnSpPr>
+        <p:spPr>
+          <a:xfrm>
+            <a:off x="91440" y="3794760"/>
+            <a:ext cx="12006072" cy="0"/>
+          </a:xfrm>
+          <a:prstGeom prst="line">
+            <a:avLst/>
+          </a:prstGeom>
+          <a:ln w="12700">
+            <a:solidFill>
+              <a:srgbClr val="D2D2D7"/>
+            </a:solidFill>
+          </a:ln>
+        </p:spPr>
+        <p:style>
+          <a:lnRef idx="2">
+            <a:schemeClr val="accent1"/>
+          </a:lnRef>
+          <a:fillRef idx="0">
+            <a:schemeClr val="accent1"/>
+          </a:fillRef>
+          <a:effectRef idx="1">
+            <a:schemeClr val="accent1"/>
+          </a:effectRef>
+          <a:fontRef idx="minor">
+            <a:schemeClr val="tx1"/>
+          </a:fontRef>
+        </p:style>
+      </p:cxnSp>
+      <p:sp>
+        <p:nvSpPr>
+          <p:cNvPr id="5" name="Rounded Rectangle 4"/>
           <p:cNvSpPr/>
           <p:nvPr/>
         </p:nvSpPr>
         <p:spPr>
           <a:xfrm>
-            <a:off x="6217920" y="1188720"/>
-            <a:ext cx="5120640" cy="4206240"/>
+            <a:off x="1783080" y="1481328"/>
+            <a:ext cx="8686800" cy="2103120"/>
           </a:xfrm>
           <a:prstGeom prst="roundRect">
             <a:avLst>
               <a:gd name="adj" fmla="val 3000"/>
             </a:avLst>
+          </a:prstGeom>
+          <a:solidFill>
+            <a:srgbClr val="F5F5F7"/>
+          </a:solidFill>
+          <a:ln w="15875">
+            <a:solidFill>
+              <a:srgbClr val="D2D2D7"/>
+            </a:solidFill>
+          </a:ln>
+        </p:spPr>
+        <p:style>
+          <a:lnRef idx="1">
+            <a:schemeClr val="accent1"/>
+          </a:lnRef>
+          <a:fillRef idx="3">
+            <a:schemeClr val="accent1"/>
+          </a:fillRef>
+          <a:effectRef idx="2">
+            <a:schemeClr val="accent1"/>
+          </a:effectRef>
+          <a:fontRef idx="minor">
+            <a:schemeClr val="lt1"/>
+          </a:fontRef>
+        </p:style>
+        <p:txBody>
+          <a:bodyPr rtlCol="0" anchor="ctr"/>
+          <a:lstStyle/>
+          <a:p>
+            <a:pPr algn="ctr"/>
+          </a:p>
+        </p:txBody>
+      </p:sp>
+      <p:sp>
+        <p:nvSpPr>
+          <p:cNvPr id="6" name="TextBox 5"/>
+          <p:cNvSpPr txBox="1"/>
+          <p:nvPr/>
+        </p:nvSpPr>
+        <p:spPr>
+          <a:xfrm>
+            <a:off x="1984248" y="1591056"/>
+            <a:ext cx="8284464" cy="310896"/>
+          </a:xfrm>
+          <a:prstGeom prst="rect">
+            <a:avLst/>
+          </a:prstGeom>
+          <a:noFill/>
+        </p:spPr>
+        <p:txBody>
+          <a:bodyPr wrap="none" anchor="ctr">
+            <a:spAutoFit/>
+          </a:bodyPr>
+          <a:lstStyle/>
+          <a:p>
+            <a:pPr algn="l"/>
+            <a:r>
+              <a:rPr sz="1100" b="1" spc="170">
+                <a:solidFill>
+                  <a:srgbClr val="C2410C"/>
+                </a:solidFill>
+                <a:latin typeface="Helvetica Neue"/>
+              </a:rPr>
+              <a:t>ML TRAINING PIPELINE</a:t>
+            </a:r>
+          </a:p>
+        </p:txBody>
+      </p:sp>
+      <p:sp>
+        <p:nvSpPr>
+          <p:cNvPr id="7" name="Rounded Rectangle 6"/>
+          <p:cNvSpPr/>
+          <p:nvPr/>
+        </p:nvSpPr>
+        <p:spPr>
+          <a:xfrm>
+            <a:off x="1783080" y="4041648"/>
+            <a:ext cx="8686800" cy="2148840"/>
+          </a:xfrm>
+          <a:prstGeom prst="roundRect">
+            <a:avLst>
+              <a:gd name="adj" fmla="val 3000"/>
+            </a:avLst>
+          </a:prstGeom>
+          <a:solidFill>
+            <a:srgbClr val="F5F5F7"/>
+          </a:solidFill>
+          <a:ln w="15875">
+            <a:solidFill>
+              <a:srgbClr val="D2D2D7"/>
+            </a:solidFill>
+          </a:ln>
+        </p:spPr>
+        <p:style>
+          <a:lnRef idx="1">
+            <a:schemeClr val="accent1"/>
+          </a:lnRef>
+          <a:fillRef idx="3">
+            <a:schemeClr val="accent1"/>
+          </a:fillRef>
+          <a:effectRef idx="2">
+            <a:schemeClr val="accent1"/>
+          </a:effectRef>
+          <a:fontRef idx="minor">
+            <a:schemeClr val="lt1"/>
+          </a:fontRef>
+        </p:style>
+        <p:txBody>
+          <a:bodyPr rtlCol="0" anchor="ctr"/>
+          <a:lstStyle/>
+          <a:p>
+            <a:pPr algn="ctr"/>
+          </a:p>
+        </p:txBody>
+      </p:sp>
+      <p:sp>
+        <p:nvSpPr>
+          <p:cNvPr id="8" name="TextBox 7"/>
+          <p:cNvSpPr txBox="1"/>
+          <p:nvPr/>
+        </p:nvSpPr>
+        <p:spPr>
+          <a:xfrm>
+            <a:off x="1984248" y="4151376"/>
+            <a:ext cx="8284464" cy="310896"/>
+          </a:xfrm>
+          <a:prstGeom prst="rect">
+            <a:avLst/>
+          </a:prstGeom>
+          <a:noFill/>
+        </p:spPr>
+        <p:txBody>
+          <a:bodyPr wrap="none" anchor="ctr">
+            <a:spAutoFit/>
+          </a:bodyPr>
+          <a:lstStyle/>
+          <a:p>
+            <a:pPr algn="l"/>
+            <a:r>
+              <a:rPr sz="1100" b="1" spc="170">
+                <a:solidFill>
+                  <a:srgbClr val="1D4ED8"/>
+                </a:solidFill>
+                <a:latin typeface="Helvetica Neue"/>
+              </a:rPr>
+              <a:t>STAGING / PROD PIPELINE</a:t>
+            </a:r>
+          </a:p>
+        </p:txBody>
+      </p:sp>
+      <p:sp>
+        <p:nvSpPr>
+          <p:cNvPr id="9" name="Can 8"/>
+          <p:cNvSpPr/>
+          <p:nvPr/>
+        </p:nvSpPr>
+        <p:spPr>
+          <a:xfrm>
+            <a:off x="475488" y="3127248"/>
+            <a:ext cx="1097280" cy="1353312"/>
+          </a:xfrm>
+          <a:prstGeom prst="can">
+            <a:avLst/>
           </a:prstGeom>
           <a:solidFill>
             <a:srgbClr val="F5F5F7"/>
@@ -4235,32 +4433,33 @@
           </a:fontRef>
         </p:style>
         <p:txBody>
-          <a:bodyPr rtlCol="0" anchor="ctr"/>
+          <a:bodyPr rtlCol="0" anchor="ctr" wrap="square"/>
           <a:lstStyle/>
           <a:p>
             <a:pPr algn="ctr"/>
             <a:r>
-              <a:rPr sz="1400">
-                <a:solidFill>
-                  <a:srgbClr val="AEAEB2"/>
-                </a:solidFill>
-                <a:latin typeface="Helvetica Neue"/>
-              </a:rPr>
-              <a:t>[ image ]</a:t>
-            </a:r>
-          </a:p>
-        </p:txBody>
-      </p:sp>
-      <p:sp>
-        <p:nvSpPr>
-          <p:cNvPr id="5" name="TextBox 4"/>
+              <a:rPr sz="1100" b="1">
+                <a:solidFill>
+                  <a:srgbClr val="424245"/>
+                </a:solidFill>
+                <a:latin typeface="Helvetica Neue"/>
+              </a:rPr>
+              <a:t>Data
+Warehouse</a:t>
+            </a:r>
+          </a:p>
+        </p:txBody>
+      </p:sp>
+      <p:sp>
+        <p:nvSpPr>
+          <p:cNvPr id="10" name="TextBox 9"/>
           <p:cNvSpPr txBox="1"/>
           <p:nvPr/>
         </p:nvSpPr>
         <p:spPr>
-          <a:xfrm>
-            <a:off x="822960" y="2468880"/>
-            <a:ext cx="4937760" cy="3200400"/>
+          <a:xfrm rot="16200000">
+            <a:off x="-731520" y="2304288"/>
+            <a:ext cx="2011680" cy="457200"/>
           </a:xfrm>
           <a:prstGeom prst="rect">
             <a:avLst/>
@@ -4268,38 +4467,1226 @@
           <a:noFill/>
         </p:spPr>
         <p:txBody>
-          <a:bodyPr wrap="square">
+          <a:bodyPr wrap="none" anchor="ctr">
             <a:spAutoFit/>
           </a:bodyPr>
           <a:lstStyle/>
           <a:p>
-            <a:pPr algn="l">
-              <a:lnSpc>
-                <a:spcPct val="130000"/>
-              </a:lnSpc>
-            </a:pPr>
-            <a:r>
-              <a:rPr sz="1800" b="0">
+            <a:pPr algn="ctr"/>
+            <a:r>
+              <a:rPr sz="1300" b="1" spc="170">
+                <a:solidFill>
+                  <a:srgbClr val="6E6E73"/>
+                </a:solidFill>
+                <a:latin typeface="Helvetica Neue"/>
+              </a:rPr>
+              <a:t>DEV</a:t>
+            </a:r>
+          </a:p>
+        </p:txBody>
+      </p:sp>
+      <p:sp>
+        <p:nvSpPr>
+          <p:cNvPr id="11" name="TextBox 10"/>
+          <p:cNvSpPr txBox="1"/>
+          <p:nvPr/>
+        </p:nvSpPr>
+        <p:spPr>
+          <a:xfrm rot="16200000">
+            <a:off x="-731520" y="4892040"/>
+            <a:ext cx="2011680" cy="457200"/>
+          </a:xfrm>
+          <a:prstGeom prst="rect">
+            <a:avLst/>
+          </a:prstGeom>
+          <a:noFill/>
+        </p:spPr>
+        <p:txBody>
+          <a:bodyPr wrap="none" anchor="ctr">
+            <a:spAutoFit/>
+          </a:bodyPr>
+          <a:lstStyle/>
+          <a:p>
+            <a:pPr algn="ctr"/>
+            <a:r>
+              <a:rPr sz="1300" b="1" spc="170">
+                <a:solidFill>
+                  <a:srgbClr val="6E6E73"/>
+                </a:solidFill>
+                <a:latin typeface="Helvetica Neue"/>
+              </a:rPr>
+              <a:t>STAGING / PROD</a:t>
+            </a:r>
+          </a:p>
+        </p:txBody>
+      </p:sp>
+      <p:sp>
+        <p:nvSpPr>
+          <p:cNvPr id="12" name="Rounded Rectangle 11"/>
+          <p:cNvSpPr/>
+          <p:nvPr/>
+        </p:nvSpPr>
+        <p:spPr>
+          <a:xfrm>
+            <a:off x="2148840" y="2240280"/>
+            <a:ext cx="1874519" cy="914400"/>
+          </a:xfrm>
+          <a:prstGeom prst="roundRect">
+            <a:avLst>
+              <a:gd name="adj" fmla="val 8000"/>
+            </a:avLst>
+          </a:prstGeom>
+          <a:solidFill>
+            <a:srgbClr val="FFF3EA"/>
+          </a:solidFill>
+          <a:ln w="22225">
+            <a:solidFill>
+              <a:srgbClr val="F97316"/>
+            </a:solidFill>
+          </a:ln>
+        </p:spPr>
+        <p:style>
+          <a:lnRef idx="1">
+            <a:schemeClr val="accent1"/>
+          </a:lnRef>
+          <a:fillRef idx="3">
+            <a:schemeClr val="accent1"/>
+          </a:fillRef>
+          <a:effectRef idx="2">
+            <a:schemeClr val="accent1"/>
+          </a:effectRef>
+          <a:fontRef idx="minor">
+            <a:schemeClr val="lt1"/>
+          </a:fontRef>
+        </p:style>
+        <p:txBody>
+          <a:bodyPr rtlCol="0" anchor="ctr" wrap="square"/>
+          <a:lstStyle/>
+          <a:p>
+            <a:pPr algn="ctr"/>
+            <a:r>
+              <a:rPr sz="1400" b="1">
+                <a:solidFill>
+                  <a:srgbClr val="C2410C"/>
+                </a:solidFill>
+                <a:latin typeface="Helvetica Neue"/>
+              </a:rPr>
+              <a:t>Data Prep</a:t>
+            </a:r>
+          </a:p>
+        </p:txBody>
+      </p:sp>
+      <p:sp>
+        <p:nvSpPr>
+          <p:cNvPr id="13" name="Rounded Rectangle 12"/>
+          <p:cNvSpPr/>
+          <p:nvPr/>
+        </p:nvSpPr>
+        <p:spPr>
+          <a:xfrm>
+            <a:off x="4617720" y="2240280"/>
+            <a:ext cx="1874519" cy="914400"/>
+          </a:xfrm>
+          <a:prstGeom prst="roundRect">
+            <a:avLst>
+              <a:gd name="adj" fmla="val 8000"/>
+            </a:avLst>
+          </a:prstGeom>
+          <a:solidFill>
+            <a:srgbClr val="FFF3EA"/>
+          </a:solidFill>
+          <a:ln w="22225">
+            <a:solidFill>
+              <a:srgbClr val="F97316"/>
+            </a:solidFill>
+          </a:ln>
+        </p:spPr>
+        <p:style>
+          <a:lnRef idx="1">
+            <a:schemeClr val="accent1"/>
+          </a:lnRef>
+          <a:fillRef idx="3">
+            <a:schemeClr val="accent1"/>
+          </a:fillRef>
+          <a:effectRef idx="2">
+            <a:schemeClr val="accent1"/>
+          </a:effectRef>
+          <a:fontRef idx="minor">
+            <a:schemeClr val="lt1"/>
+          </a:fontRef>
+        </p:style>
+        <p:txBody>
+          <a:bodyPr rtlCol="0" anchor="ctr" wrap="square"/>
+          <a:lstStyle/>
+          <a:p>
+            <a:pPr algn="ctr"/>
+            <a:r>
+              <a:rPr sz="1400" b="1">
+                <a:solidFill>
+                  <a:srgbClr val="C2410C"/>
+                </a:solidFill>
+                <a:latin typeface="Helvetica Neue"/>
+              </a:rPr>
+              <a:t>Model Training</a:t>
+            </a:r>
+          </a:p>
+        </p:txBody>
+      </p:sp>
+      <p:sp>
+        <p:nvSpPr>
+          <p:cNvPr id="14" name="Rounded Rectangle 13"/>
+          <p:cNvSpPr/>
+          <p:nvPr/>
+        </p:nvSpPr>
+        <p:spPr>
+          <a:xfrm>
+            <a:off x="7086600" y="2240280"/>
+            <a:ext cx="1874519" cy="914400"/>
+          </a:xfrm>
+          <a:prstGeom prst="roundRect">
+            <a:avLst>
+              <a:gd name="adj" fmla="val 8000"/>
+            </a:avLst>
+          </a:prstGeom>
+          <a:solidFill>
+            <a:srgbClr val="FFF3EA"/>
+          </a:solidFill>
+          <a:ln w="22225">
+            <a:solidFill>
+              <a:srgbClr val="F97316"/>
+            </a:solidFill>
+          </a:ln>
+        </p:spPr>
+        <p:style>
+          <a:lnRef idx="1">
+            <a:schemeClr val="accent1"/>
+          </a:lnRef>
+          <a:fillRef idx="3">
+            <a:schemeClr val="accent1"/>
+          </a:fillRef>
+          <a:effectRef idx="2">
+            <a:schemeClr val="accent1"/>
+          </a:effectRef>
+          <a:fontRef idx="minor">
+            <a:schemeClr val="lt1"/>
+          </a:fontRef>
+        </p:style>
+        <p:txBody>
+          <a:bodyPr rtlCol="0" anchor="ctr" wrap="square"/>
+          <a:lstStyle/>
+          <a:p>
+            <a:pPr algn="ctr"/>
+            <a:r>
+              <a:rPr sz="1400" b="1">
+                <a:solidFill>
+                  <a:srgbClr val="C2410C"/>
+                </a:solidFill>
+                <a:latin typeface="Helvetica Neue"/>
+              </a:rPr>
+              <a:t>Model Validation</a:t>
+            </a:r>
+          </a:p>
+        </p:txBody>
+      </p:sp>
+      <p:cxnSp>
+        <p:nvCxnSpPr>
+          <p:cNvPr id="15" name="Connector 14"/>
+          <p:cNvCxnSpPr/>
+          <p:nvPr/>
+        </p:nvCxnSpPr>
+        <p:spPr>
+          <a:xfrm>
+            <a:off x="4023360" y="2697480"/>
+            <a:ext cx="594360" cy="0"/>
+          </a:xfrm>
+          <a:prstGeom prst="line">
+            <a:avLst/>
+          </a:prstGeom>
+          <a:ln w="19050">
+            <a:solidFill>
+              <a:srgbClr val="AEAEB2"/>
+            </a:solidFill>
+            <a:tailEnd type="triangle" w="med" len="med"/>
+          </a:ln>
+        </p:spPr>
+        <p:style>
+          <a:lnRef idx="2">
+            <a:schemeClr val="accent1"/>
+          </a:lnRef>
+          <a:fillRef idx="0">
+            <a:schemeClr val="accent1"/>
+          </a:fillRef>
+          <a:effectRef idx="1">
+            <a:schemeClr val="accent1"/>
+          </a:effectRef>
+          <a:fontRef idx="minor">
+            <a:schemeClr val="tx1"/>
+          </a:fontRef>
+        </p:style>
+      </p:cxnSp>
+      <p:cxnSp>
+        <p:nvCxnSpPr>
+          <p:cNvPr id="16" name="Connector 15"/>
+          <p:cNvCxnSpPr/>
+          <p:nvPr/>
+        </p:nvCxnSpPr>
+        <p:spPr>
+          <a:xfrm>
+            <a:off x="6492240" y="2697480"/>
+            <a:ext cx="594360" cy="0"/>
+          </a:xfrm>
+          <a:prstGeom prst="line">
+            <a:avLst/>
+          </a:prstGeom>
+          <a:ln w="19050">
+            <a:solidFill>
+              <a:srgbClr val="AEAEB2"/>
+            </a:solidFill>
+            <a:tailEnd type="triangle" w="med" len="med"/>
+          </a:ln>
+        </p:spPr>
+        <p:style>
+          <a:lnRef idx="2">
+            <a:schemeClr val="accent1"/>
+          </a:lnRef>
+          <a:fillRef idx="0">
+            <a:schemeClr val="accent1"/>
+          </a:fillRef>
+          <a:effectRef idx="1">
+            <a:schemeClr val="accent1"/>
+          </a:effectRef>
+          <a:fontRef idx="minor">
+            <a:schemeClr val="tx1"/>
+          </a:fontRef>
+        </p:style>
+      </p:cxnSp>
+      <p:cxnSp>
+        <p:nvCxnSpPr>
+          <p:cNvPr id="17" name="Connector 16"/>
+          <p:cNvCxnSpPr/>
+          <p:nvPr/>
+        </p:nvCxnSpPr>
+        <p:spPr>
+          <a:xfrm flipV="1">
+            <a:off x="8023860" y="1828800"/>
+            <a:ext cx="0" cy="411480"/>
+          </a:xfrm>
+          <a:prstGeom prst="line">
+            <a:avLst/>
+          </a:prstGeom>
+          <a:ln w="15875">
+            <a:solidFill>
+              <a:srgbClr val="AEAEB2"/>
+            </a:solidFill>
+          </a:ln>
+        </p:spPr>
+        <p:style>
+          <a:lnRef idx="2">
+            <a:schemeClr val="accent1"/>
+          </a:lnRef>
+          <a:fillRef idx="0">
+            <a:schemeClr val="accent1"/>
+          </a:fillRef>
+          <a:effectRef idx="1">
+            <a:schemeClr val="accent1"/>
+          </a:effectRef>
+          <a:fontRef idx="minor">
+            <a:schemeClr val="tx1"/>
+          </a:fontRef>
+        </p:style>
+      </p:cxnSp>
+      <p:cxnSp>
+        <p:nvCxnSpPr>
+          <p:cNvPr id="18" name="Connector 17"/>
+          <p:cNvCxnSpPr/>
+          <p:nvPr/>
+        </p:nvCxnSpPr>
+        <p:spPr>
+          <a:xfrm flipH="1">
+            <a:off x="5554979" y="1828800"/>
+            <a:ext cx="2468881" cy="0"/>
+          </a:xfrm>
+          <a:prstGeom prst="line">
+            <a:avLst/>
+          </a:prstGeom>
+          <a:ln w="15875">
+            <a:solidFill>
+              <a:srgbClr val="AEAEB2"/>
+            </a:solidFill>
+          </a:ln>
+        </p:spPr>
+        <p:style>
+          <a:lnRef idx="2">
+            <a:schemeClr val="accent1"/>
+          </a:lnRef>
+          <a:fillRef idx="0">
+            <a:schemeClr val="accent1"/>
+          </a:fillRef>
+          <a:effectRef idx="1">
+            <a:schemeClr val="accent1"/>
+          </a:effectRef>
+          <a:fontRef idx="minor">
+            <a:schemeClr val="tx1"/>
+          </a:fontRef>
+        </p:style>
+      </p:cxnSp>
+      <p:cxnSp>
+        <p:nvCxnSpPr>
+          <p:cNvPr id="19" name="Connector 18"/>
+          <p:cNvCxnSpPr/>
+          <p:nvPr/>
+        </p:nvCxnSpPr>
+        <p:spPr>
+          <a:xfrm>
+            <a:off x="5554979" y="1828800"/>
+            <a:ext cx="0" cy="411480"/>
+          </a:xfrm>
+          <a:prstGeom prst="line">
+            <a:avLst/>
+          </a:prstGeom>
+          <a:ln w="15875">
+            <a:solidFill>
+              <a:srgbClr val="AEAEB2"/>
+            </a:solidFill>
+            <a:tailEnd type="triangle" w="med" len="med"/>
+          </a:ln>
+        </p:spPr>
+        <p:style>
+          <a:lnRef idx="2">
+            <a:schemeClr val="accent1"/>
+          </a:lnRef>
+          <a:fillRef idx="0">
+            <a:schemeClr val="accent1"/>
+          </a:fillRef>
+          <a:effectRef idx="1">
+            <a:schemeClr val="accent1"/>
+          </a:effectRef>
+          <a:fontRef idx="minor">
+            <a:schemeClr val="tx1"/>
+          </a:fontRef>
+        </p:style>
+      </p:cxnSp>
+      <p:sp>
+        <p:nvSpPr>
+          <p:cNvPr id="20" name="TextBox 19"/>
+          <p:cNvSpPr txBox="1"/>
+          <p:nvPr/>
+        </p:nvSpPr>
+        <p:spPr>
+          <a:xfrm>
+            <a:off x="5554979" y="1517904"/>
+            <a:ext cx="2468880" cy="274320"/>
+          </a:xfrm>
+          <a:prstGeom prst="rect">
+            <a:avLst/>
+          </a:prstGeom>
+          <a:noFill/>
+        </p:spPr>
+        <p:txBody>
+          <a:bodyPr wrap="none" anchor="ctr">
+            <a:spAutoFit/>
+          </a:bodyPr>
+          <a:lstStyle/>
+          <a:p>
+            <a:pPr algn="ctr"/>
+            <a:r>
+              <a:rPr sz="1000" b="1" spc="170">
+                <a:solidFill>
+                  <a:srgbClr val="6E6E73"/>
+                </a:solidFill>
+                <a:latin typeface="Helvetica Neue"/>
+              </a:rPr>
+              <a:t>HYPERPARAMETER TUNING</a:t>
+            </a:r>
+          </a:p>
+        </p:txBody>
+      </p:sp>
+      <p:sp>
+        <p:nvSpPr>
+          <p:cNvPr id="21" name="Document 20"/>
+          <p:cNvSpPr/>
+          <p:nvPr/>
+        </p:nvSpPr>
+        <p:spPr>
+          <a:xfrm>
+            <a:off x="9281160" y="2240280"/>
+            <a:ext cx="1143000" cy="914400"/>
+          </a:xfrm>
+          <a:prstGeom prst="flowChartDocument">
+            <a:avLst/>
+          </a:prstGeom>
+          <a:solidFill>
+            <a:srgbClr val="FFF3EA"/>
+          </a:solidFill>
+          <a:ln w="19050">
+            <a:solidFill>
+              <a:srgbClr val="F97316"/>
+            </a:solidFill>
+          </a:ln>
+        </p:spPr>
+        <p:style>
+          <a:lnRef idx="1">
+            <a:schemeClr val="accent1"/>
+          </a:lnRef>
+          <a:fillRef idx="3">
+            <a:schemeClr val="accent1"/>
+          </a:fillRef>
+          <a:effectRef idx="2">
+            <a:schemeClr val="accent1"/>
+          </a:effectRef>
+          <a:fontRef idx="minor">
+            <a:schemeClr val="lt1"/>
+          </a:fontRef>
+        </p:style>
+        <p:txBody>
+          <a:bodyPr rtlCol="0" anchor="ctr" wrap="square"/>
+          <a:lstStyle/>
+          <a:p>
+            <a:pPr algn="ctr"/>
+            <a:r>
+              <a:rPr sz="1100" b="1">
+                <a:solidFill>
+                  <a:srgbClr val="C2410C"/>
+                </a:solidFill>
+                <a:latin typeface="Helvetica Neue"/>
+              </a:rPr>
+              <a:t>Trained
+model</a:t>
+            </a:r>
+          </a:p>
+        </p:txBody>
+      </p:sp>
+      <p:cxnSp>
+        <p:nvCxnSpPr>
+          <p:cNvPr id="22" name="Connector 21"/>
+          <p:cNvCxnSpPr/>
+          <p:nvPr/>
+        </p:nvCxnSpPr>
+        <p:spPr>
+          <a:xfrm>
+            <a:off x="8961120" y="2697480"/>
+            <a:ext cx="320040" cy="0"/>
+          </a:xfrm>
+          <a:prstGeom prst="line">
+            <a:avLst/>
+          </a:prstGeom>
+          <a:ln w="19050">
+            <a:solidFill>
+              <a:srgbClr val="AEAEB2"/>
+            </a:solidFill>
+            <a:tailEnd type="triangle" w="med" len="med"/>
+          </a:ln>
+        </p:spPr>
+        <p:style>
+          <a:lnRef idx="2">
+            <a:schemeClr val="accent1"/>
+          </a:lnRef>
+          <a:fillRef idx="0">
+            <a:schemeClr val="accent1"/>
+          </a:fillRef>
+          <a:effectRef idx="1">
+            <a:schemeClr val="accent1"/>
+          </a:effectRef>
+          <a:fontRef idx="minor">
+            <a:schemeClr val="tx1"/>
+          </a:fontRef>
+        </p:style>
+      </p:cxnSp>
+      <p:sp>
+        <p:nvSpPr>
+          <p:cNvPr id="23" name="Rounded Rectangle 22"/>
+          <p:cNvSpPr/>
+          <p:nvPr/>
+        </p:nvSpPr>
+        <p:spPr>
+          <a:xfrm>
+            <a:off x="2148840" y="4709160"/>
+            <a:ext cx="1874519" cy="914400"/>
+          </a:xfrm>
+          <a:prstGeom prst="roundRect">
+            <a:avLst>
+              <a:gd name="adj" fmla="val 8000"/>
+            </a:avLst>
+          </a:prstGeom>
+          <a:solidFill>
+            <a:srgbClr val="FFFFFF"/>
+          </a:solidFill>
+          <a:ln w="19050">
+            <a:solidFill>
+              <a:srgbClr val="D2D2D7"/>
+            </a:solidFill>
+          </a:ln>
+        </p:spPr>
+        <p:style>
+          <a:lnRef idx="1">
+            <a:schemeClr val="accent1"/>
+          </a:lnRef>
+          <a:fillRef idx="3">
+            <a:schemeClr val="accent1"/>
+          </a:fillRef>
+          <a:effectRef idx="2">
+            <a:schemeClr val="accent1"/>
+          </a:effectRef>
+          <a:fontRef idx="minor">
+            <a:schemeClr val="lt1"/>
+          </a:fontRef>
+        </p:style>
+        <p:txBody>
+          <a:bodyPr rtlCol="0" anchor="ctr" wrap="square"/>
+          <a:lstStyle/>
+          <a:p>
+            <a:pPr algn="ctr"/>
+            <a:r>
+              <a:rPr sz="1400" b="1">
                 <a:solidFill>
                   <a:srgbClr val="424245"/>
                 </a:solidFill>
                 <a:latin typeface="Helvetica Neue"/>
               </a:rPr>
-              <a:t>Body sits left; image fills the right half.</a:t>
-            </a:r>
-          </a:p>
-        </p:txBody>
-      </p:sp>
-      <p:sp>
-        <p:nvSpPr>
-          <p:cNvPr id="6" name="TextBox 5"/>
+              <a:t>Data Prep</a:t>
+            </a:r>
+          </a:p>
+        </p:txBody>
+      </p:sp>
+      <p:sp>
+        <p:nvSpPr>
+          <p:cNvPr id="24" name="Rounded Rectangle 23"/>
+          <p:cNvSpPr/>
+          <p:nvPr/>
+        </p:nvSpPr>
+        <p:spPr>
+          <a:xfrm>
+            <a:off x="4617720" y="4709160"/>
+            <a:ext cx="1874519" cy="914400"/>
+          </a:xfrm>
+          <a:prstGeom prst="roundRect">
+            <a:avLst>
+              <a:gd name="adj" fmla="val 8000"/>
+            </a:avLst>
+          </a:prstGeom>
+          <a:solidFill>
+            <a:srgbClr val="FFFFFF"/>
+          </a:solidFill>
+          <a:ln w="19050">
+            <a:solidFill>
+              <a:srgbClr val="D2D2D7"/>
+            </a:solidFill>
+          </a:ln>
+        </p:spPr>
+        <p:style>
+          <a:lnRef idx="1">
+            <a:schemeClr val="accent1"/>
+          </a:lnRef>
+          <a:fillRef idx="3">
+            <a:schemeClr val="accent1"/>
+          </a:fillRef>
+          <a:effectRef idx="2">
+            <a:schemeClr val="accent1"/>
+          </a:effectRef>
+          <a:fontRef idx="minor">
+            <a:schemeClr val="lt1"/>
+          </a:fontRef>
+        </p:style>
+        <p:txBody>
+          <a:bodyPr rtlCol="0" anchor="ctr" wrap="square"/>
+          <a:lstStyle/>
+          <a:p>
+            <a:pPr algn="ctr"/>
+            <a:r>
+              <a:rPr sz="1400" b="1">
+                <a:solidFill>
+                  <a:srgbClr val="424245"/>
+                </a:solidFill>
+                <a:latin typeface="Helvetica Neue"/>
+              </a:rPr>
+              <a:t>Retrain</a:t>
+            </a:r>
+          </a:p>
+        </p:txBody>
+      </p:sp>
+      <p:sp>
+        <p:nvSpPr>
+          <p:cNvPr id="25" name="Rounded Rectangle 24"/>
+          <p:cNvSpPr/>
+          <p:nvPr/>
+        </p:nvSpPr>
+        <p:spPr>
+          <a:xfrm>
+            <a:off x="7086600" y="4709160"/>
+            <a:ext cx="1874519" cy="914400"/>
+          </a:xfrm>
+          <a:prstGeom prst="roundRect">
+            <a:avLst>
+              <a:gd name="adj" fmla="val 8000"/>
+            </a:avLst>
+          </a:prstGeom>
+          <a:solidFill>
+            <a:srgbClr val="FFFFFF"/>
+          </a:solidFill>
+          <a:ln w="19050">
+            <a:solidFill>
+              <a:srgbClr val="D2D2D7"/>
+            </a:solidFill>
+          </a:ln>
+        </p:spPr>
+        <p:style>
+          <a:lnRef idx="1">
+            <a:schemeClr val="accent1"/>
+          </a:lnRef>
+          <a:fillRef idx="3">
+            <a:schemeClr val="accent1"/>
+          </a:fillRef>
+          <a:effectRef idx="2">
+            <a:schemeClr val="accent1"/>
+          </a:effectRef>
+          <a:fontRef idx="minor">
+            <a:schemeClr val="lt1"/>
+          </a:fontRef>
+        </p:style>
+        <p:txBody>
+          <a:bodyPr rtlCol="0" anchor="ctr" wrap="square"/>
+          <a:lstStyle/>
+          <a:p>
+            <a:pPr algn="ctr"/>
+            <a:r>
+              <a:rPr sz="1400" b="1">
+                <a:solidFill>
+                  <a:srgbClr val="424245"/>
+                </a:solidFill>
+                <a:latin typeface="Helvetica Neue"/>
+              </a:rPr>
+              <a:t>Validate</a:t>
+            </a:r>
+          </a:p>
+        </p:txBody>
+      </p:sp>
+      <p:cxnSp>
+        <p:nvCxnSpPr>
+          <p:cNvPr id="26" name="Connector 25"/>
+          <p:cNvCxnSpPr/>
+          <p:nvPr/>
+        </p:nvCxnSpPr>
+        <p:spPr>
+          <a:xfrm>
+            <a:off x="4023360" y="5166360"/>
+            <a:ext cx="594360" cy="0"/>
+          </a:xfrm>
+          <a:prstGeom prst="line">
+            <a:avLst/>
+          </a:prstGeom>
+          <a:ln w="19050">
+            <a:solidFill>
+              <a:srgbClr val="AEAEB2"/>
+            </a:solidFill>
+            <a:tailEnd type="triangle" w="med" len="med"/>
+          </a:ln>
+        </p:spPr>
+        <p:style>
+          <a:lnRef idx="2">
+            <a:schemeClr val="accent1"/>
+          </a:lnRef>
+          <a:fillRef idx="0">
+            <a:schemeClr val="accent1"/>
+          </a:fillRef>
+          <a:effectRef idx="1">
+            <a:schemeClr val="accent1"/>
+          </a:effectRef>
+          <a:fontRef idx="minor">
+            <a:schemeClr val="tx1"/>
+          </a:fontRef>
+        </p:style>
+      </p:cxnSp>
+      <p:cxnSp>
+        <p:nvCxnSpPr>
+          <p:cNvPr id="27" name="Connector 26"/>
+          <p:cNvCxnSpPr/>
+          <p:nvPr/>
+        </p:nvCxnSpPr>
+        <p:spPr>
+          <a:xfrm>
+            <a:off x="6492240" y="5166360"/>
+            <a:ext cx="594360" cy="0"/>
+          </a:xfrm>
+          <a:prstGeom prst="line">
+            <a:avLst/>
+          </a:prstGeom>
+          <a:ln w="19050">
+            <a:solidFill>
+              <a:srgbClr val="AEAEB2"/>
+            </a:solidFill>
+            <a:tailEnd type="triangle" w="med" len="med"/>
+          </a:ln>
+        </p:spPr>
+        <p:style>
+          <a:lnRef idx="2">
+            <a:schemeClr val="accent1"/>
+          </a:lnRef>
+          <a:fillRef idx="0">
+            <a:schemeClr val="accent1"/>
+          </a:fillRef>
+          <a:effectRef idx="1">
+            <a:schemeClr val="accent1"/>
+          </a:effectRef>
+          <a:fontRef idx="minor">
+            <a:schemeClr val="tx1"/>
+          </a:fontRef>
+        </p:style>
+      </p:cxnSp>
+      <p:sp>
+        <p:nvSpPr>
+          <p:cNvPr id="28" name="Diamond 27"/>
+          <p:cNvSpPr/>
+          <p:nvPr/>
+        </p:nvSpPr>
+        <p:spPr>
+          <a:xfrm>
+            <a:off x="9189720" y="4572000"/>
+            <a:ext cx="1280160" cy="1188720"/>
+          </a:xfrm>
+          <a:prstGeom prst="diamond">
+            <a:avLst/>
+          </a:prstGeom>
+          <a:solidFill>
+            <a:srgbClr val="FFFFFF"/>
+          </a:solidFill>
+          <a:ln w="19050">
+            <a:solidFill>
+              <a:srgbClr val="2563EB"/>
+            </a:solidFill>
+          </a:ln>
+        </p:spPr>
+        <p:style>
+          <a:lnRef idx="1">
+            <a:schemeClr val="accent1"/>
+          </a:lnRef>
+          <a:fillRef idx="3">
+            <a:schemeClr val="accent1"/>
+          </a:fillRef>
+          <a:effectRef idx="2">
+            <a:schemeClr val="accent1"/>
+          </a:effectRef>
+          <a:fontRef idx="minor">
+            <a:schemeClr val="lt1"/>
+          </a:fontRef>
+        </p:style>
+        <p:txBody>
+          <a:bodyPr rtlCol="0" anchor="ctr" wrap="square"/>
+          <a:lstStyle/>
+          <a:p>
+            <a:pPr algn="ctr"/>
+            <a:r>
+              <a:rPr sz="1000" b="1">
+                <a:solidFill>
+                  <a:srgbClr val="1D4ED8"/>
+                </a:solidFill>
+                <a:latin typeface="Helvetica Neue"/>
+              </a:rPr>
+              <a:t>Perf
+drop?</a:t>
+            </a:r>
+          </a:p>
+        </p:txBody>
+      </p:sp>
+      <p:cxnSp>
+        <p:nvCxnSpPr>
+          <p:cNvPr id="29" name="Connector 28"/>
+          <p:cNvCxnSpPr/>
+          <p:nvPr/>
+        </p:nvCxnSpPr>
+        <p:spPr>
+          <a:xfrm>
+            <a:off x="8961120" y="5166360"/>
+            <a:ext cx="228600" cy="0"/>
+          </a:xfrm>
+          <a:prstGeom prst="line">
+            <a:avLst/>
+          </a:prstGeom>
+          <a:ln w="19050">
+            <a:solidFill>
+              <a:srgbClr val="AEAEB2"/>
+            </a:solidFill>
+            <a:tailEnd type="triangle" w="med" len="med"/>
+          </a:ln>
+        </p:spPr>
+        <p:style>
+          <a:lnRef idx="2">
+            <a:schemeClr val="accent1"/>
+          </a:lnRef>
+          <a:fillRef idx="0">
+            <a:schemeClr val="accent1"/>
+          </a:fillRef>
+          <a:effectRef idx="1">
+            <a:schemeClr val="accent1"/>
+          </a:effectRef>
+          <a:fontRef idx="minor">
+            <a:schemeClr val="tx1"/>
+          </a:fontRef>
+        </p:style>
+      </p:cxnSp>
+      <p:cxnSp>
+        <p:nvCxnSpPr>
+          <p:cNvPr id="30" name="Connector 29"/>
+          <p:cNvCxnSpPr/>
+          <p:nvPr/>
+        </p:nvCxnSpPr>
+        <p:spPr>
+          <a:xfrm>
+            <a:off x="9829800" y="5623560"/>
+            <a:ext cx="0" cy="365760"/>
+          </a:xfrm>
+          <a:prstGeom prst="line">
+            <a:avLst/>
+          </a:prstGeom>
+          <a:ln w="15875">
+            <a:solidFill>
+              <a:srgbClr val="AEAEB2"/>
+            </a:solidFill>
+          </a:ln>
+        </p:spPr>
+        <p:style>
+          <a:lnRef idx="2">
+            <a:schemeClr val="accent1"/>
+          </a:lnRef>
+          <a:fillRef idx="0">
+            <a:schemeClr val="accent1"/>
+          </a:fillRef>
+          <a:effectRef idx="1">
+            <a:schemeClr val="accent1"/>
+          </a:effectRef>
+          <a:fontRef idx="minor">
+            <a:schemeClr val="tx1"/>
+          </a:fontRef>
+        </p:style>
+      </p:cxnSp>
+      <p:cxnSp>
+        <p:nvCxnSpPr>
+          <p:cNvPr id="31" name="Connector 30"/>
+          <p:cNvCxnSpPr/>
+          <p:nvPr/>
+        </p:nvCxnSpPr>
+        <p:spPr>
+          <a:xfrm flipH="1">
+            <a:off x="3086100" y="5989320"/>
+            <a:ext cx="6743700" cy="0"/>
+          </a:xfrm>
+          <a:prstGeom prst="line">
+            <a:avLst/>
+          </a:prstGeom>
+          <a:ln w="15875">
+            <a:solidFill>
+              <a:srgbClr val="AEAEB2"/>
+            </a:solidFill>
+          </a:ln>
+        </p:spPr>
+        <p:style>
+          <a:lnRef idx="2">
+            <a:schemeClr val="accent1"/>
+          </a:lnRef>
+          <a:fillRef idx="0">
+            <a:schemeClr val="accent1"/>
+          </a:fillRef>
+          <a:effectRef idx="1">
+            <a:schemeClr val="accent1"/>
+          </a:effectRef>
+          <a:fontRef idx="minor">
+            <a:schemeClr val="tx1"/>
+          </a:fontRef>
+        </p:style>
+      </p:cxnSp>
+      <p:cxnSp>
+        <p:nvCxnSpPr>
+          <p:cNvPr id="32" name="Connector 31"/>
+          <p:cNvCxnSpPr/>
+          <p:nvPr/>
+        </p:nvCxnSpPr>
+        <p:spPr>
+          <a:xfrm flipV="1">
+            <a:off x="3086100" y="5623560"/>
+            <a:ext cx="0" cy="365760"/>
+          </a:xfrm>
+          <a:prstGeom prst="line">
+            <a:avLst/>
+          </a:prstGeom>
+          <a:ln w="15875">
+            <a:solidFill>
+              <a:srgbClr val="AEAEB2"/>
+            </a:solidFill>
+            <a:tailEnd type="triangle" w="med" len="med"/>
+          </a:ln>
+        </p:spPr>
+        <p:style>
+          <a:lnRef idx="2">
+            <a:schemeClr val="accent1"/>
+          </a:lnRef>
+          <a:fillRef idx="0">
+            <a:schemeClr val="accent1"/>
+          </a:fillRef>
+          <a:effectRef idx="1">
+            <a:schemeClr val="accent1"/>
+          </a:effectRef>
+          <a:fontRef idx="minor">
+            <a:schemeClr val="tx1"/>
+          </a:fontRef>
+        </p:style>
+      </p:cxnSp>
+      <p:sp>
+        <p:nvSpPr>
+          <p:cNvPr id="33" name="TextBox 32"/>
           <p:cNvSpPr txBox="1"/>
           <p:nvPr/>
         </p:nvSpPr>
         <p:spPr>
           <a:xfrm>
-            <a:off x="6217920" y="5486400"/>
-            <a:ext cx="5120640" cy="365760"/>
+            <a:off x="8869680" y="5971032"/>
+            <a:ext cx="1005840" cy="274320"/>
+          </a:xfrm>
+          <a:prstGeom prst="rect">
+            <a:avLst/>
+          </a:prstGeom>
+          <a:noFill/>
+        </p:spPr>
+        <p:txBody>
+          <a:bodyPr wrap="none" anchor="ctr">
+            <a:spAutoFit/>
+          </a:bodyPr>
+          <a:lstStyle/>
+          <a:p>
+            <a:pPr algn="l"/>
+            <a:r>
+              <a:rPr sz="900" b="1" spc="170">
+                <a:solidFill>
+                  <a:srgbClr val="1D4ED8"/>
+                </a:solidFill>
+                <a:latin typeface="Helvetica Neue"/>
+              </a:rPr>
+              <a:t>YES</a:t>
+            </a:r>
+          </a:p>
+        </p:txBody>
+      </p:sp>
+      <p:cxnSp>
+        <p:nvCxnSpPr>
+          <p:cNvPr id="34" name="Connector 33"/>
+          <p:cNvCxnSpPr/>
+          <p:nvPr/>
+        </p:nvCxnSpPr>
+        <p:spPr>
+          <a:xfrm flipV="1">
+            <a:off x="1572768" y="2834640"/>
+            <a:ext cx="576072" cy="548640"/>
+          </a:xfrm>
+          <a:prstGeom prst="line">
+            <a:avLst/>
+          </a:prstGeom>
+          <a:ln w="19050">
+            <a:solidFill>
+              <a:srgbClr val="AEAEB2"/>
+            </a:solidFill>
+            <a:tailEnd type="triangle" w="med" len="med"/>
+          </a:ln>
+        </p:spPr>
+        <p:style>
+          <a:lnRef idx="2">
+            <a:schemeClr val="accent1"/>
+          </a:lnRef>
+          <a:fillRef idx="0">
+            <a:schemeClr val="accent1"/>
+          </a:fillRef>
+          <a:effectRef idx="1">
+            <a:schemeClr val="accent1"/>
+          </a:effectRef>
+          <a:fontRef idx="minor">
+            <a:schemeClr val="tx1"/>
+          </a:fontRef>
+        </p:style>
+      </p:cxnSp>
+      <p:sp>
+        <p:nvSpPr>
+          <p:cNvPr id="35" name="TextBox 34"/>
+          <p:cNvSpPr txBox="1"/>
+          <p:nvPr/>
+        </p:nvSpPr>
+        <p:spPr>
+          <a:xfrm>
+            <a:off x="946404" y="2834640"/>
+            <a:ext cx="1828800" cy="274320"/>
+          </a:xfrm>
+          <a:prstGeom prst="rect">
+            <a:avLst/>
+          </a:prstGeom>
+          <a:noFill/>
+        </p:spPr>
+        <p:txBody>
+          <a:bodyPr wrap="none" anchor="ctr">
+            <a:spAutoFit/>
+          </a:bodyPr>
+          <a:lstStyle/>
+          <a:p>
+            <a:pPr algn="ctr"/>
+            <a:r>
+              <a:rPr sz="900" b="1" spc="170">
+                <a:solidFill>
+                  <a:srgbClr val="6E6E73"/>
+                </a:solidFill>
+                <a:latin typeface="Helvetica Neue"/>
+              </a:rPr>
+              <a:t>POC DATA</a:t>
+            </a:r>
+          </a:p>
+        </p:txBody>
+      </p:sp>
+      <p:cxnSp>
+        <p:nvCxnSpPr>
+          <p:cNvPr id="36" name="Connector 35"/>
+          <p:cNvCxnSpPr/>
+          <p:nvPr/>
+        </p:nvCxnSpPr>
+        <p:spPr>
+          <a:xfrm>
+            <a:off x="1572768" y="4251960"/>
+            <a:ext cx="576072" cy="777240"/>
+          </a:xfrm>
+          <a:prstGeom prst="line">
+            <a:avLst/>
+          </a:prstGeom>
+          <a:ln w="19050">
+            <a:solidFill>
+              <a:srgbClr val="AEAEB2"/>
+            </a:solidFill>
+            <a:tailEnd type="triangle" w="med" len="med"/>
+          </a:ln>
+        </p:spPr>
+        <p:style>
+          <a:lnRef idx="2">
+            <a:schemeClr val="accent1"/>
+          </a:lnRef>
+          <a:fillRef idx="0">
+            <a:schemeClr val="accent1"/>
+          </a:fillRef>
+          <a:effectRef idx="1">
+            <a:schemeClr val="accent1"/>
+          </a:effectRef>
+          <a:fontRef idx="minor">
+            <a:schemeClr val="tx1"/>
+          </a:fontRef>
+        </p:style>
+      </p:cxnSp>
+      <p:sp>
+        <p:nvSpPr>
+          <p:cNvPr id="37" name="TextBox 36"/>
+          <p:cNvSpPr txBox="1"/>
+          <p:nvPr/>
+        </p:nvSpPr>
+        <p:spPr>
+          <a:xfrm>
+            <a:off x="946404" y="4366260"/>
+            <a:ext cx="1828800" cy="274320"/>
+          </a:xfrm>
+          <a:prstGeom prst="rect">
+            <a:avLst/>
+          </a:prstGeom>
+          <a:noFill/>
+        </p:spPr>
+        <p:txBody>
+          <a:bodyPr wrap="none" anchor="ctr">
+            <a:spAutoFit/>
+          </a:bodyPr>
+          <a:lstStyle/>
+          <a:p>
+            <a:pPr algn="ctr"/>
+            <a:r>
+              <a:rPr sz="900" b="1" spc="170">
+                <a:solidFill>
+                  <a:srgbClr val="6E6E73"/>
+                </a:solidFill>
+                <a:latin typeface="Helvetica Neue"/>
+              </a:rPr>
+              <a:t>BATCH FETCH</a:t>
+            </a:r>
+          </a:p>
+        </p:txBody>
+      </p:sp>
+      <p:cxnSp>
+        <p:nvCxnSpPr>
+          <p:cNvPr id="38" name="Connector 37"/>
+          <p:cNvCxnSpPr/>
+          <p:nvPr/>
+        </p:nvCxnSpPr>
+        <p:spPr>
+          <a:xfrm>
+            <a:off x="9829800" y="3154680"/>
+            <a:ext cx="0" cy="886968"/>
+          </a:xfrm>
+          <a:prstGeom prst="line">
+            <a:avLst/>
+          </a:prstGeom>
+          <a:ln w="19050">
+            <a:solidFill>
+              <a:srgbClr val="AEAEB2"/>
+            </a:solidFill>
+            <a:tailEnd type="triangle" w="med" len="med"/>
+          </a:ln>
+        </p:spPr>
+        <p:style>
+          <a:lnRef idx="2">
+            <a:schemeClr val="accent1"/>
+          </a:lnRef>
+          <a:fillRef idx="0">
+            <a:schemeClr val="accent1"/>
+          </a:fillRef>
+          <a:effectRef idx="1">
+            <a:schemeClr val="accent1"/>
+          </a:effectRef>
+          <a:fontRef idx="minor">
+            <a:schemeClr val="tx1"/>
+          </a:fontRef>
+        </p:style>
+      </p:cxnSp>
+      <p:sp>
+        <p:nvSpPr>
+          <p:cNvPr id="39" name="TextBox 38"/>
+          <p:cNvSpPr txBox="1"/>
+          <p:nvPr/>
+        </p:nvSpPr>
+        <p:spPr>
+          <a:xfrm>
+            <a:off x="8915400" y="3323844"/>
+            <a:ext cx="1828800" cy="274320"/>
+          </a:xfrm>
+          <a:prstGeom prst="rect">
+            <a:avLst/>
+          </a:prstGeom>
+          <a:noFill/>
+        </p:spPr>
+        <p:txBody>
+          <a:bodyPr wrap="none" anchor="ctr">
+            <a:spAutoFit/>
+          </a:bodyPr>
+          <a:lstStyle/>
+          <a:p>
+            <a:pPr algn="ctr"/>
+            <a:r>
+              <a:rPr sz="900" b="1" spc="170">
+                <a:solidFill>
+                  <a:srgbClr val="6E6E73"/>
+                </a:solidFill>
+                <a:latin typeface="Helvetica Neue"/>
+              </a:rPr>
+              <a:t>DEPLOY</a:t>
+            </a:r>
+          </a:p>
+        </p:txBody>
+      </p:sp>
+      <p:sp>
+        <p:nvSpPr>
+          <p:cNvPr id="40" name="TextBox 39"/>
+          <p:cNvSpPr txBox="1"/>
+          <p:nvPr/>
+        </p:nvSpPr>
+        <p:spPr>
+          <a:xfrm>
+            <a:off x="365760" y="6446520"/>
+            <a:ext cx="5486400" cy="320040"/>
           </a:xfrm>
           <a:prstGeom prst="rect">
             <a:avLst/>
@@ -4318,52 +5705,13 @@
               </a:lnSpc>
             </a:pPr>
             <a:r>
-              <a:rPr sz="1300" b="0">
-                <a:solidFill>
-                  <a:srgbClr val="6E6E73"/>
-                </a:solidFill>
-                <a:latin typeface="Helvetica Neue"/>
-              </a:rPr>
-              <a:t>Figure 1 — caption in Slate</a:t>
-            </a:r>
-          </a:p>
-        </p:txBody>
-      </p:sp>
-      <p:sp>
-        <p:nvSpPr>
-          <p:cNvPr id="7" name="TextBox 6"/>
-          <p:cNvSpPr txBox="1"/>
-          <p:nvPr/>
-        </p:nvSpPr>
-        <p:spPr>
-          <a:xfrm>
-            <a:off x="365760" y="6446520"/>
-            <a:ext cx="5486400" cy="320040"/>
-          </a:xfrm>
-          <a:prstGeom prst="rect">
-            <a:avLst/>
-          </a:prstGeom>
-          <a:noFill/>
-        </p:spPr>
-        <p:txBody>
-          <a:bodyPr wrap="square">
-            <a:spAutoFit/>
-          </a:bodyPr>
-          <a:lstStyle/>
-          <a:p>
-            <a:pPr algn="l">
-              <a:lnSpc>
-                <a:spcPct val="112000"/>
-              </a:lnSpc>
-            </a:pPr>
-            <a:r>
               <a:rPr sz="900" b="0">
                 <a:solidFill>
                   <a:srgbClr val="AEAEB2"/>
                 </a:solidFill>
                 <a:latin typeface="Helvetica Neue"/>
               </a:rPr>
-              <a:t>10 · Image + caption</a:t>
+              <a:t>9d · Architecture — swim-lane</a:t>
             </a:r>
           </a:p>
         </p:txBody>
@@ -4394,86 +5742,8 @@
         </p:nvSpPr>
         <p:spPr>
           <a:xfrm>
-            <a:off x="1097280" y="2194560"/>
-            <a:ext cx="10058400" cy="1828800"/>
-          </a:xfrm>
-          <a:prstGeom prst="rect">
-            <a:avLst/>
-          </a:prstGeom>
-          <a:noFill/>
-        </p:spPr>
-        <p:txBody>
-          <a:bodyPr wrap="square">
-            <a:spAutoFit/>
-          </a:bodyPr>
-          <a:lstStyle/>
-          <a:p>
-            <a:pPr algn="ctr">
-              <a:lnSpc>
-                <a:spcPct val="120000"/>
-              </a:lnSpc>
-            </a:pPr>
-            <a:r>
-              <a:rPr sz="3600" b="1" spc="-40">
-                <a:solidFill>
-                  <a:srgbClr val="1D1D1F"/>
-                </a:solidFill>
-                <a:latin typeface="Helvetica Neue"/>
-              </a:rPr>
-              <a:t>“Good design is as little design as possible.”</a:t>
-            </a:r>
-          </a:p>
-        </p:txBody>
-      </p:sp>
-      <p:sp>
-        <p:nvSpPr>
-          <p:cNvPr id="3" name="TextBox 2"/>
-          <p:cNvSpPr txBox="1"/>
-          <p:nvPr/>
-        </p:nvSpPr>
-        <p:spPr>
-          <a:xfrm>
-            <a:off x="1097280" y="4023360"/>
-            <a:ext cx="10058400" cy="457200"/>
-          </a:xfrm>
-          <a:prstGeom prst="rect">
-            <a:avLst/>
-          </a:prstGeom>
-          <a:noFill/>
-        </p:spPr>
-        <p:txBody>
-          <a:bodyPr wrap="square">
-            <a:spAutoFit/>
-          </a:bodyPr>
-          <a:lstStyle/>
-          <a:p>
-            <a:pPr algn="ctr">
-              <a:lnSpc>
-                <a:spcPct val="112000"/>
-              </a:lnSpc>
-            </a:pPr>
-            <a:r>
-              <a:rPr sz="1600" b="0">
-                <a:solidFill>
-                  <a:srgbClr val="6E6E73"/>
-                </a:solidFill>
-                <a:latin typeface="Helvetica Neue"/>
-              </a:rPr>
-              <a:t>— Dieter Rams</a:t>
-            </a:r>
-          </a:p>
-        </p:txBody>
-      </p:sp>
-      <p:sp>
-        <p:nvSpPr>
-          <p:cNvPr id="4" name="TextBox 3"/>
-          <p:cNvSpPr txBox="1"/>
-          <p:nvPr/>
-        </p:nvSpPr>
-        <p:spPr>
-          <a:xfrm>
-            <a:off x="365760" y="6446520"/>
-            <a:ext cx="5486400" cy="320040"/>
+            <a:off x="822960" y="822960"/>
+            <a:ext cx="5486400" cy="365760"/>
           </a:xfrm>
           <a:prstGeom prst="rect">
             <a:avLst/>
@@ -4492,13 +5762,225 @@
               </a:lnSpc>
             </a:pPr>
             <a:r>
+              <a:rPr sz="1200" b="1" spc="170">
+                <a:solidFill>
+                  <a:srgbClr val="1D4ED8"/>
+                </a:solidFill>
+                <a:latin typeface="Helvetica Neue"/>
+              </a:rPr>
+              <a:t>VISUAL</a:t>
+            </a:r>
+          </a:p>
+        </p:txBody>
+      </p:sp>
+      <p:sp>
+        <p:nvSpPr>
+          <p:cNvPr id="3" name="TextBox 2"/>
+          <p:cNvSpPr txBox="1"/>
+          <p:nvPr/>
+        </p:nvSpPr>
+        <p:spPr>
+          <a:xfrm>
+            <a:off x="786384" y="1234440"/>
+            <a:ext cx="5486400" cy="1463040"/>
+          </a:xfrm>
+          <a:prstGeom prst="rect">
+            <a:avLst/>
+          </a:prstGeom>
+          <a:noFill/>
+        </p:spPr>
+        <p:txBody>
+          <a:bodyPr wrap="square">
+            <a:spAutoFit/>
+          </a:bodyPr>
+          <a:lstStyle/>
+          <a:p>
+            <a:pPr algn="l">
+              <a:lnSpc>
+                <a:spcPct val="112000"/>
+              </a:lnSpc>
+            </a:pPr>
+            <a:r>
+              <a:rPr sz="3400" b="1" spc="-40">
+                <a:solidFill>
+                  <a:srgbClr val="1D1D1F"/>
+                </a:solidFill>
+                <a:latin typeface="Helvetica Neue"/>
+              </a:rPr>
+              <a:t>Image + caption</a:t>
+            </a:r>
+          </a:p>
+        </p:txBody>
+      </p:sp>
+      <p:sp>
+        <p:nvSpPr>
+          <p:cNvPr id="4" name="Rounded Rectangle 3"/>
+          <p:cNvSpPr/>
+          <p:nvPr/>
+        </p:nvSpPr>
+        <p:spPr>
+          <a:xfrm>
+            <a:off x="6217920" y="1188720"/>
+            <a:ext cx="5120640" cy="4206240"/>
+          </a:xfrm>
+          <a:prstGeom prst="roundRect">
+            <a:avLst>
+              <a:gd name="adj" fmla="val 3000"/>
+            </a:avLst>
+          </a:prstGeom>
+          <a:solidFill>
+            <a:srgbClr val="F5F5F7"/>
+          </a:solidFill>
+          <a:ln w="19050">
+            <a:solidFill>
+              <a:srgbClr val="D2D2D7"/>
+            </a:solidFill>
+          </a:ln>
+        </p:spPr>
+        <p:style>
+          <a:lnRef idx="1">
+            <a:schemeClr val="accent1"/>
+          </a:lnRef>
+          <a:fillRef idx="3">
+            <a:schemeClr val="accent1"/>
+          </a:fillRef>
+          <a:effectRef idx="2">
+            <a:schemeClr val="accent1"/>
+          </a:effectRef>
+          <a:fontRef idx="minor">
+            <a:schemeClr val="lt1"/>
+          </a:fontRef>
+        </p:style>
+        <p:txBody>
+          <a:bodyPr rtlCol="0" anchor="ctr"/>
+          <a:lstStyle/>
+          <a:p>
+            <a:pPr algn="ctr"/>
+            <a:r>
+              <a:rPr sz="1400">
+                <a:solidFill>
+                  <a:srgbClr val="AEAEB2"/>
+                </a:solidFill>
+                <a:latin typeface="Helvetica Neue"/>
+              </a:rPr>
+              <a:t>[ image ]</a:t>
+            </a:r>
+          </a:p>
+        </p:txBody>
+      </p:sp>
+      <p:sp>
+        <p:nvSpPr>
+          <p:cNvPr id="5" name="TextBox 4"/>
+          <p:cNvSpPr txBox="1"/>
+          <p:nvPr/>
+        </p:nvSpPr>
+        <p:spPr>
+          <a:xfrm>
+            <a:off x="822960" y="2468880"/>
+            <a:ext cx="4937760" cy="3200400"/>
+          </a:xfrm>
+          <a:prstGeom prst="rect">
+            <a:avLst/>
+          </a:prstGeom>
+          <a:noFill/>
+        </p:spPr>
+        <p:txBody>
+          <a:bodyPr wrap="square">
+            <a:spAutoFit/>
+          </a:bodyPr>
+          <a:lstStyle/>
+          <a:p>
+            <a:pPr algn="l">
+              <a:lnSpc>
+                <a:spcPct val="130000"/>
+              </a:lnSpc>
+            </a:pPr>
+            <a:r>
+              <a:rPr sz="1800" b="0">
+                <a:solidFill>
+                  <a:srgbClr val="424245"/>
+                </a:solidFill>
+                <a:latin typeface="Helvetica Neue"/>
+              </a:rPr>
+              <a:t>Body sits left; image fills the right half.</a:t>
+            </a:r>
+          </a:p>
+        </p:txBody>
+      </p:sp>
+      <p:sp>
+        <p:nvSpPr>
+          <p:cNvPr id="6" name="TextBox 5"/>
+          <p:cNvSpPr txBox="1"/>
+          <p:nvPr/>
+        </p:nvSpPr>
+        <p:spPr>
+          <a:xfrm>
+            <a:off x="6217920" y="5486400"/>
+            <a:ext cx="5120640" cy="365760"/>
+          </a:xfrm>
+          <a:prstGeom prst="rect">
+            <a:avLst/>
+          </a:prstGeom>
+          <a:noFill/>
+        </p:spPr>
+        <p:txBody>
+          <a:bodyPr wrap="square">
+            <a:spAutoFit/>
+          </a:bodyPr>
+          <a:lstStyle/>
+          <a:p>
+            <a:pPr algn="l">
+              <a:lnSpc>
+                <a:spcPct val="112000"/>
+              </a:lnSpc>
+            </a:pPr>
+            <a:r>
+              <a:rPr sz="1300" b="0">
+                <a:solidFill>
+                  <a:srgbClr val="6E6E73"/>
+                </a:solidFill>
+                <a:latin typeface="Helvetica Neue"/>
+              </a:rPr>
+              <a:t>Figure 1 — caption in Slate</a:t>
+            </a:r>
+          </a:p>
+        </p:txBody>
+      </p:sp>
+      <p:sp>
+        <p:nvSpPr>
+          <p:cNvPr id="7" name="TextBox 6"/>
+          <p:cNvSpPr txBox="1"/>
+          <p:nvPr/>
+        </p:nvSpPr>
+        <p:spPr>
+          <a:xfrm>
+            <a:off x="365760" y="6446520"/>
+            <a:ext cx="5486400" cy="320040"/>
+          </a:xfrm>
+          <a:prstGeom prst="rect">
+            <a:avLst/>
+          </a:prstGeom>
+          <a:noFill/>
+        </p:spPr>
+        <p:txBody>
+          <a:bodyPr wrap="square">
+            <a:spAutoFit/>
+          </a:bodyPr>
+          <a:lstStyle/>
+          <a:p>
+            <a:pPr algn="l">
+              <a:lnSpc>
+                <a:spcPct val="112000"/>
+              </a:lnSpc>
+            </a:pPr>
+            <a:r>
               <a:rPr sz="900" b="0">
                 <a:solidFill>
                   <a:srgbClr val="AEAEB2"/>
                 </a:solidFill>
                 <a:latin typeface="Helvetica Neue"/>
               </a:rPr>
-              <a:t>11 · Quote</a:t>
+              <a:t>10 · Image + caption</a:t>
             </a:r>
           </a:p>
         </p:txBody>
@@ -4512,6 +5994,141 @@
 </file>
 
 <file path=ppt/slides/slide14.xml><?xml version="1.0" encoding="utf-8"?>
+<p:sld xmlns:a="http://schemas.openxmlformats.org/drawingml/2006/main" xmlns:p="http://schemas.openxmlformats.org/presentationml/2006/main" xmlns:r="http://schemas.openxmlformats.org/officeDocument/2006/relationships">
+  <p:cSld>
+    <p:spTree>
+      <p:nvGrpSpPr>
+        <p:cNvPr id="1" name=""/>
+        <p:cNvGrpSpPr/>
+        <p:nvPr/>
+      </p:nvGrpSpPr>
+      <p:grpSpPr/>
+      <p:sp>
+        <p:nvSpPr>
+          <p:cNvPr id="2" name="TextBox 1"/>
+          <p:cNvSpPr txBox="1"/>
+          <p:nvPr/>
+        </p:nvSpPr>
+        <p:spPr>
+          <a:xfrm>
+            <a:off x="1097280" y="2194560"/>
+            <a:ext cx="10058400" cy="1828800"/>
+          </a:xfrm>
+          <a:prstGeom prst="rect">
+            <a:avLst/>
+          </a:prstGeom>
+          <a:noFill/>
+        </p:spPr>
+        <p:txBody>
+          <a:bodyPr wrap="square">
+            <a:spAutoFit/>
+          </a:bodyPr>
+          <a:lstStyle/>
+          <a:p>
+            <a:pPr algn="ctr">
+              <a:lnSpc>
+                <a:spcPct val="120000"/>
+              </a:lnSpc>
+            </a:pPr>
+            <a:r>
+              <a:rPr sz="3600" b="1" spc="-40">
+                <a:solidFill>
+                  <a:srgbClr val="1D1D1F"/>
+                </a:solidFill>
+                <a:latin typeface="Helvetica Neue"/>
+              </a:rPr>
+              <a:t>“Good design is as little design as possible.”</a:t>
+            </a:r>
+          </a:p>
+        </p:txBody>
+      </p:sp>
+      <p:sp>
+        <p:nvSpPr>
+          <p:cNvPr id="3" name="TextBox 2"/>
+          <p:cNvSpPr txBox="1"/>
+          <p:nvPr/>
+        </p:nvSpPr>
+        <p:spPr>
+          <a:xfrm>
+            <a:off x="1097280" y="4023360"/>
+            <a:ext cx="10058400" cy="457200"/>
+          </a:xfrm>
+          <a:prstGeom prst="rect">
+            <a:avLst/>
+          </a:prstGeom>
+          <a:noFill/>
+        </p:spPr>
+        <p:txBody>
+          <a:bodyPr wrap="square">
+            <a:spAutoFit/>
+          </a:bodyPr>
+          <a:lstStyle/>
+          <a:p>
+            <a:pPr algn="ctr">
+              <a:lnSpc>
+                <a:spcPct val="112000"/>
+              </a:lnSpc>
+            </a:pPr>
+            <a:r>
+              <a:rPr sz="1600" b="0">
+                <a:solidFill>
+                  <a:srgbClr val="6E6E73"/>
+                </a:solidFill>
+                <a:latin typeface="Helvetica Neue"/>
+              </a:rPr>
+              <a:t>— Dieter Rams</a:t>
+            </a:r>
+          </a:p>
+        </p:txBody>
+      </p:sp>
+      <p:sp>
+        <p:nvSpPr>
+          <p:cNvPr id="4" name="TextBox 3"/>
+          <p:cNvSpPr txBox="1"/>
+          <p:nvPr/>
+        </p:nvSpPr>
+        <p:spPr>
+          <a:xfrm>
+            <a:off x="365760" y="6446520"/>
+            <a:ext cx="5486400" cy="320040"/>
+          </a:xfrm>
+          <a:prstGeom prst="rect">
+            <a:avLst/>
+          </a:prstGeom>
+          <a:noFill/>
+        </p:spPr>
+        <p:txBody>
+          <a:bodyPr wrap="square">
+            <a:spAutoFit/>
+          </a:bodyPr>
+          <a:lstStyle/>
+          <a:p>
+            <a:pPr algn="l">
+              <a:lnSpc>
+                <a:spcPct val="112000"/>
+              </a:lnSpc>
+            </a:pPr>
+            <a:r>
+              <a:rPr sz="900" b="0">
+                <a:solidFill>
+                  <a:srgbClr val="AEAEB2"/>
+                </a:solidFill>
+                <a:latin typeface="Helvetica Neue"/>
+              </a:rPr>
+              <a:t>11 · Quote</a:t>
+            </a:r>
+          </a:p>
+        </p:txBody>
+      </p:sp>
+    </p:spTree>
+  </p:cSld>
+  <p:clrMapOvr>
+    <a:masterClrMapping/>
+  </p:clrMapOvr>
+</p:sld>
+</file>
+
+<file path=ppt/slides/slide15.xml><?xml version="1.0" encoding="utf-8"?>
 <p:sld xmlns:a="http://schemas.openxmlformats.org/drawingml/2006/main" xmlns:p="http://schemas.openxmlformats.org/presentationml/2006/main" xmlns:r="http://schemas.openxmlformats.org/officeDocument/2006/relationships">
   <p:cSld>
     <p:spTree>

</xml_diff>

<commit_message>
feat: polish swim-lane diagram — refined native + publication-grade SVG
Native (arch_swimlane): orthogonal rounded connectors, thin lines + small
arrowheads, tighter boxes, white-chip labels — fixes the crude straight-diagonal
routing. SVG (arch_swimlane_svg): draw.io-quality vector in our palette
(chevron arrows, smooth orthogonal routing, cylinder/document/diamond),
embedded full-slide. Gallery now 16 slides; guide documents both forms.

Co-Authored-By: Claude Opus 4.8 <noreply@anthropic.com>
</commit_message>
<xml_diff>
--- a/dist/slide-style.pptx
+++ b/dist/slide-style.pptx
@@ -20,6 +20,7 @@
     <p:sldId id="268" r:id="rId19"/>
     <p:sldId id="269" r:id="rId20"/>
     <p:sldId id="270" r:id="rId21"/>
+    <p:sldId id="271" r:id="rId22"/>
   </p:sldIdLst>
   <p:sldSz cx="12192000" cy="6858000" type="screen4x3"/>
   <p:notesSz cx="6858000" cy="9144000"/>
@@ -4528,8 +4529,8 @@
         </p:nvSpPr>
         <p:spPr>
           <a:xfrm>
-            <a:off x="2148840" y="2240280"/>
-            <a:ext cx="1874519" cy="914400"/>
+            <a:off x="2148840" y="2286000"/>
+            <a:ext cx="1874519" cy="731520"/>
           </a:xfrm>
           <a:prstGeom prst="roundRect">
             <a:avLst>
@@ -4584,8 +4585,8 @@
         </p:nvSpPr>
         <p:spPr>
           <a:xfrm>
-            <a:off x="4617720" y="2240280"/>
-            <a:ext cx="1874519" cy="914400"/>
+            <a:off x="4617720" y="2286000"/>
+            <a:ext cx="1874519" cy="731520"/>
           </a:xfrm>
           <a:prstGeom prst="roundRect">
             <a:avLst>
@@ -4640,8 +4641,8 @@
         </p:nvSpPr>
         <p:spPr>
           <a:xfrm>
-            <a:off x="7086600" y="2240280"/>
-            <a:ext cx="1874519" cy="914400"/>
+            <a:off x="7086600" y="2286000"/>
+            <a:ext cx="1874519" cy="731520"/>
           </a:xfrm>
           <a:prstGeom prst="roundRect">
             <a:avLst>
@@ -4696,17 +4697,17 @@
         </p:nvCxnSpPr>
         <p:spPr>
           <a:xfrm>
-            <a:off x="4023360" y="2697480"/>
+            <a:off x="4023360" y="2651760"/>
             <a:ext cx="594360" cy="0"/>
           </a:xfrm>
           <a:prstGeom prst="line">
             <a:avLst/>
           </a:prstGeom>
-          <a:ln w="19050">
+          <a:ln w="12700">
             <a:solidFill>
-              <a:srgbClr val="AEAEB2"/>
+              <a:srgbClr val="B4B7BD"/>
             </a:solidFill>
-            <a:tailEnd type="triangle" w="med" len="med"/>
+            <a:tailEnd type="triangle" w="sm" len="sm"/>
           </a:ln>
         </p:spPr>
         <p:style>
@@ -4732,17 +4733,17 @@
         </p:nvCxnSpPr>
         <p:spPr>
           <a:xfrm>
-            <a:off x="6492240" y="2697480"/>
+            <a:off x="6492240" y="2651760"/>
             <a:ext cx="594360" cy="0"/>
           </a:xfrm>
           <a:prstGeom prst="line">
             <a:avLst/>
           </a:prstGeom>
-          <a:ln w="19050">
+          <a:ln w="12700">
             <a:solidFill>
-              <a:srgbClr val="AEAEB2"/>
+              <a:srgbClr val="B4B7BD"/>
             </a:solidFill>
-            <a:tailEnd type="triangle" w="med" len="med"/>
+            <a:tailEnd type="triangle" w="sm" len="sm"/>
           </a:ln>
         </p:spPr>
         <p:style>
@@ -4768,15 +4769,15 @@
         </p:nvCxnSpPr>
         <p:spPr>
           <a:xfrm flipV="1">
-            <a:off x="8023860" y="1828800"/>
-            <a:ext cx="0" cy="411480"/>
+            <a:off x="8023860" y="1920240"/>
+            <a:ext cx="0" cy="365760"/>
           </a:xfrm>
           <a:prstGeom prst="line">
             <a:avLst/>
           </a:prstGeom>
-          <a:ln w="15875">
+          <a:ln w="12700">
             <a:solidFill>
-              <a:srgbClr val="AEAEB2"/>
+              <a:srgbClr val="B4B7BD"/>
             </a:solidFill>
           </a:ln>
         </p:spPr>
@@ -4803,15 +4804,15 @@
         </p:nvCxnSpPr>
         <p:spPr>
           <a:xfrm flipH="1">
-            <a:off x="5554979" y="1828800"/>
+            <a:off x="5554979" y="1920240"/>
             <a:ext cx="2468881" cy="0"/>
           </a:xfrm>
           <a:prstGeom prst="line">
             <a:avLst/>
           </a:prstGeom>
-          <a:ln w="15875">
+          <a:ln w="12700">
             <a:solidFill>
-              <a:srgbClr val="AEAEB2"/>
+              <a:srgbClr val="B4B7BD"/>
             </a:solidFill>
           </a:ln>
         </p:spPr>
@@ -4838,17 +4839,17 @@
         </p:nvCxnSpPr>
         <p:spPr>
           <a:xfrm>
-            <a:off x="5554979" y="1828800"/>
-            <a:ext cx="0" cy="411480"/>
+            <a:off x="5554979" y="1920240"/>
+            <a:ext cx="0" cy="365760"/>
           </a:xfrm>
           <a:prstGeom prst="line">
             <a:avLst/>
           </a:prstGeom>
-          <a:ln w="15875">
+          <a:ln w="12700">
             <a:solidFill>
-              <a:srgbClr val="AEAEB2"/>
+              <a:srgbClr val="B4B7BD"/>
             </a:solidFill>
-            <a:tailEnd type="triangle" w="med" len="med"/>
+            <a:tailEnd type="triangle" w="sm" len="sm"/>
           </a:ln>
         </p:spPr>
         <p:style>
@@ -4874,7 +4875,7 @@
         </p:nvSpPr>
         <p:spPr>
           <a:xfrm>
-            <a:off x="5554979" y="1517904"/>
+            <a:off x="5554979" y="1627632"/>
             <a:ext cx="2468880" cy="274320"/>
           </a:xfrm>
           <a:prstGeom prst="rect">
@@ -4909,8 +4910,8 @@
         </p:nvSpPr>
         <p:spPr>
           <a:xfrm>
-            <a:off x="9281160" y="2240280"/>
-            <a:ext cx="1143000" cy="914400"/>
+            <a:off x="9326880" y="2286000"/>
+            <a:ext cx="1097280" cy="731520"/>
           </a:xfrm>
           <a:prstGeom prst="flowChartDocument">
             <a:avLst/>
@@ -4964,17 +4965,17 @@
         </p:nvCxnSpPr>
         <p:spPr>
           <a:xfrm>
-            <a:off x="8961120" y="2697480"/>
-            <a:ext cx="320040" cy="0"/>
+            <a:off x="8961120" y="2651760"/>
+            <a:ext cx="365760" cy="0"/>
           </a:xfrm>
           <a:prstGeom prst="line">
             <a:avLst/>
           </a:prstGeom>
-          <a:ln w="19050">
+          <a:ln w="12700">
             <a:solidFill>
-              <a:srgbClr val="AEAEB2"/>
+              <a:srgbClr val="B4B7BD"/>
             </a:solidFill>
-            <a:tailEnd type="triangle" w="med" len="med"/>
+            <a:tailEnd type="triangle" w="sm" len="sm"/>
           </a:ln>
         </p:spPr>
         <p:style>
@@ -5000,8 +5001,8 @@
         </p:nvSpPr>
         <p:spPr>
           <a:xfrm>
-            <a:off x="2148840" y="4709160"/>
-            <a:ext cx="1874519" cy="914400"/>
+            <a:off x="2148840" y="4754880"/>
+            <a:ext cx="1874519" cy="731520"/>
           </a:xfrm>
           <a:prstGeom prst="roundRect">
             <a:avLst>
@@ -5056,8 +5057,8 @@
         </p:nvSpPr>
         <p:spPr>
           <a:xfrm>
-            <a:off x="4617720" y="4709160"/>
-            <a:ext cx="1874519" cy="914400"/>
+            <a:off x="4617720" y="4754880"/>
+            <a:ext cx="1874519" cy="731520"/>
           </a:xfrm>
           <a:prstGeom prst="roundRect">
             <a:avLst>
@@ -5112,8 +5113,8 @@
         </p:nvSpPr>
         <p:spPr>
           <a:xfrm>
-            <a:off x="7086600" y="4709160"/>
-            <a:ext cx="1874519" cy="914400"/>
+            <a:off x="7086600" y="4754880"/>
+            <a:ext cx="1874519" cy="731520"/>
           </a:xfrm>
           <a:prstGeom prst="roundRect">
             <a:avLst>
@@ -5168,17 +5169,17 @@
         </p:nvCxnSpPr>
         <p:spPr>
           <a:xfrm>
-            <a:off x="4023360" y="5166360"/>
+            <a:off x="4023360" y="5120640"/>
             <a:ext cx="594360" cy="0"/>
           </a:xfrm>
           <a:prstGeom prst="line">
             <a:avLst/>
           </a:prstGeom>
-          <a:ln w="19050">
+          <a:ln w="12700">
             <a:solidFill>
-              <a:srgbClr val="AEAEB2"/>
+              <a:srgbClr val="B4B7BD"/>
             </a:solidFill>
-            <a:tailEnd type="triangle" w="med" len="med"/>
+            <a:tailEnd type="triangle" w="sm" len="sm"/>
           </a:ln>
         </p:spPr>
         <p:style>
@@ -5204,17 +5205,17 @@
         </p:nvCxnSpPr>
         <p:spPr>
           <a:xfrm>
-            <a:off x="6492240" y="5166360"/>
+            <a:off x="6492240" y="5120640"/>
             <a:ext cx="594360" cy="0"/>
           </a:xfrm>
           <a:prstGeom prst="line">
             <a:avLst/>
           </a:prstGeom>
-          <a:ln w="19050">
+          <a:ln w="12700">
             <a:solidFill>
-              <a:srgbClr val="AEAEB2"/>
+              <a:srgbClr val="B4B7BD"/>
             </a:solidFill>
-            <a:tailEnd type="triangle" w="med" len="med"/>
+            <a:tailEnd type="triangle" w="sm" len="sm"/>
           </a:ln>
         </p:spPr>
         <p:style>
@@ -5240,8 +5241,8 @@
         </p:nvSpPr>
         <p:spPr>
           <a:xfrm>
-            <a:off x="9189720" y="4572000"/>
-            <a:ext cx="1280160" cy="1188720"/>
+            <a:off x="9144000" y="4572000"/>
+            <a:ext cx="1097280" cy="1097280"/>
           </a:xfrm>
           <a:prstGeom prst="diamond">
             <a:avLst/>
@@ -5295,17 +5296,17 @@
         </p:nvCxnSpPr>
         <p:spPr>
           <a:xfrm>
-            <a:off x="8961120" y="5166360"/>
-            <a:ext cx="228600" cy="0"/>
+            <a:off x="8961120" y="5120640"/>
+            <a:ext cx="182880" cy="0"/>
           </a:xfrm>
           <a:prstGeom prst="line">
             <a:avLst/>
           </a:prstGeom>
-          <a:ln w="19050">
+          <a:ln w="12700">
             <a:solidFill>
-              <a:srgbClr val="AEAEB2"/>
+              <a:srgbClr val="B4B7BD"/>
             </a:solidFill>
-            <a:tailEnd type="triangle" w="med" len="med"/>
+            <a:tailEnd type="triangle" w="sm" len="sm"/>
           </a:ln>
         </p:spPr>
         <p:style>
@@ -5331,15 +5332,15 @@
         </p:nvCxnSpPr>
         <p:spPr>
           <a:xfrm>
-            <a:off x="9829800" y="5623560"/>
-            <a:ext cx="0" cy="365760"/>
+            <a:off x="9692640" y="5669280"/>
+            <a:ext cx="0" cy="320040"/>
           </a:xfrm>
           <a:prstGeom prst="line">
             <a:avLst/>
           </a:prstGeom>
-          <a:ln w="15875">
+          <a:ln w="12700">
             <a:solidFill>
-              <a:srgbClr val="AEAEB2"/>
+              <a:srgbClr val="B4B7BD"/>
             </a:solidFill>
           </a:ln>
         </p:spPr>
@@ -5367,14 +5368,14 @@
         <p:spPr>
           <a:xfrm flipH="1">
             <a:off x="3086100" y="5989320"/>
-            <a:ext cx="6743700" cy="0"/>
+            <a:ext cx="6606540" cy="0"/>
           </a:xfrm>
           <a:prstGeom prst="line">
             <a:avLst/>
           </a:prstGeom>
-          <a:ln w="15875">
+          <a:ln w="12700">
             <a:solidFill>
-              <a:srgbClr val="AEAEB2"/>
+              <a:srgbClr val="B4B7BD"/>
             </a:solidFill>
           </a:ln>
         </p:spPr>
@@ -5401,17 +5402,17 @@
         </p:nvCxnSpPr>
         <p:spPr>
           <a:xfrm flipV="1">
-            <a:off x="3086100" y="5623560"/>
-            <a:ext cx="0" cy="365760"/>
+            <a:off x="3086100" y="5486400"/>
+            <a:ext cx="0" cy="502920"/>
           </a:xfrm>
           <a:prstGeom prst="line">
             <a:avLst/>
           </a:prstGeom>
-          <a:ln w="15875">
+          <a:ln w="12700">
             <a:solidFill>
-              <a:srgbClr val="AEAEB2"/>
+              <a:srgbClr val="B4B7BD"/>
             </a:solidFill>
-            <a:tailEnd type="triangle" w="med" len="med"/>
+            <a:tailEnd type="triangle" w="sm" len="sm"/>
           </a:ln>
         </p:spPr>
         <p:style>
@@ -5437,8 +5438,8 @@
         </p:nvSpPr>
         <p:spPr>
           <a:xfrm>
-            <a:off x="8869680" y="5971032"/>
-            <a:ext cx="1005840" cy="274320"/>
+            <a:off x="9802367" y="5687568"/>
+            <a:ext cx="640080" cy="274320"/>
           </a:xfrm>
           <a:prstGeom prst="rect">
             <a:avLst/>
@@ -5471,18 +5472,17 @@
           <p:nvPr/>
         </p:nvCxnSpPr>
         <p:spPr>
-          <a:xfrm flipV="1">
-            <a:off x="1572768" y="2834640"/>
-            <a:ext cx="576072" cy="548640"/>
+          <a:xfrm>
+            <a:off x="1572768" y="3291840"/>
+            <a:ext cx="301751" cy="0"/>
           </a:xfrm>
           <a:prstGeom prst="line">
             <a:avLst/>
           </a:prstGeom>
-          <a:ln w="19050">
+          <a:ln w="12700">
             <a:solidFill>
-              <a:srgbClr val="AEAEB2"/>
+              <a:srgbClr val="B4B7BD"/>
             </a:solidFill>
-            <a:tailEnd type="triangle" w="med" len="med"/>
           </a:ln>
         </p:spPr>
         <p:style>
@@ -5500,60 +5500,24 @@
           </a:fontRef>
         </p:style>
       </p:cxnSp>
-      <p:sp>
-        <p:nvSpPr>
-          <p:cNvPr id="35" name="TextBox 34"/>
-          <p:cNvSpPr txBox="1"/>
-          <p:nvPr/>
-        </p:nvSpPr>
-        <p:spPr>
-          <a:xfrm>
-            <a:off x="946404" y="2834640"/>
-            <a:ext cx="1828800" cy="274320"/>
-          </a:xfrm>
-          <a:prstGeom prst="rect">
-            <a:avLst/>
-          </a:prstGeom>
-          <a:noFill/>
-        </p:spPr>
-        <p:txBody>
-          <a:bodyPr wrap="none" anchor="ctr">
-            <a:spAutoFit/>
-          </a:bodyPr>
-          <a:lstStyle/>
-          <a:p>
-            <a:pPr algn="ctr"/>
-            <a:r>
-              <a:rPr sz="900" b="1" spc="170">
-                <a:solidFill>
-                  <a:srgbClr val="6E6E73"/>
-                </a:solidFill>
-                <a:latin typeface="Helvetica Neue"/>
-              </a:rPr>
-              <a:t>POC DATA</a:t>
-            </a:r>
-          </a:p>
-        </p:txBody>
-      </p:sp>
       <p:cxnSp>
         <p:nvCxnSpPr>
-          <p:cNvPr id="36" name="Connector 35"/>
+          <p:cNvPr id="35" name="Connector 34"/>
           <p:cNvCxnSpPr/>
           <p:nvPr/>
         </p:nvCxnSpPr>
         <p:spPr>
-          <a:xfrm>
-            <a:off x="1572768" y="4251960"/>
-            <a:ext cx="576072" cy="777240"/>
+          <a:xfrm flipV="1">
+            <a:off x="1874519" y="2651760"/>
+            <a:ext cx="0" cy="640080"/>
           </a:xfrm>
           <a:prstGeom prst="line">
             <a:avLst/>
           </a:prstGeom>
-          <a:ln w="19050">
+          <a:ln w="12700">
             <a:solidFill>
-              <a:srgbClr val="AEAEB2"/>
+              <a:srgbClr val="B4B7BD"/>
             </a:solidFill>
-            <a:tailEnd type="triangle" w="med" len="med"/>
           </a:ln>
         </p:spPr>
         <p:style>
@@ -5571,60 +5535,25 @@
           </a:fontRef>
         </p:style>
       </p:cxnSp>
-      <p:sp>
-        <p:nvSpPr>
-          <p:cNvPr id="37" name="TextBox 36"/>
-          <p:cNvSpPr txBox="1"/>
-          <p:nvPr/>
-        </p:nvSpPr>
-        <p:spPr>
-          <a:xfrm>
-            <a:off x="946404" y="4366260"/>
-            <a:ext cx="1828800" cy="274320"/>
-          </a:xfrm>
-          <a:prstGeom prst="rect">
-            <a:avLst/>
-          </a:prstGeom>
-          <a:noFill/>
-        </p:spPr>
-        <p:txBody>
-          <a:bodyPr wrap="none" anchor="ctr">
-            <a:spAutoFit/>
-          </a:bodyPr>
-          <a:lstStyle/>
-          <a:p>
-            <a:pPr algn="ctr"/>
-            <a:r>
-              <a:rPr sz="900" b="1" spc="170">
-                <a:solidFill>
-                  <a:srgbClr val="6E6E73"/>
-                </a:solidFill>
-                <a:latin typeface="Helvetica Neue"/>
-              </a:rPr>
-              <a:t>BATCH FETCH</a:t>
-            </a:r>
-          </a:p>
-        </p:txBody>
-      </p:sp>
       <p:cxnSp>
         <p:nvCxnSpPr>
-          <p:cNvPr id="38" name="Connector 37"/>
+          <p:cNvPr id="36" name="Connector 35"/>
           <p:cNvCxnSpPr/>
           <p:nvPr/>
         </p:nvCxnSpPr>
         <p:spPr>
           <a:xfrm>
-            <a:off x="9829800" y="3154680"/>
-            <a:ext cx="0" cy="886968"/>
+            <a:off x="1874519" y="2651760"/>
+            <a:ext cx="274321" cy="0"/>
           </a:xfrm>
           <a:prstGeom prst="line">
             <a:avLst/>
           </a:prstGeom>
-          <a:ln w="19050">
+          <a:ln w="12700">
             <a:solidFill>
-              <a:srgbClr val="AEAEB2"/>
+              <a:srgbClr val="B4B7BD"/>
             </a:solidFill>
-            <a:tailEnd type="triangle" w="med" len="med"/>
+            <a:tailEnd type="triangle" w="sm" len="sm"/>
           </a:ln>
         </p:spPr>
         <p:style>
@@ -5644,14 +5573,57 @@
       </p:cxnSp>
       <p:sp>
         <p:nvSpPr>
-          <p:cNvPr id="39" name="TextBox 38"/>
+          <p:cNvPr id="37" name="Rectangle 36"/>
+          <p:cNvSpPr/>
+          <p:nvPr/>
+        </p:nvSpPr>
+        <p:spPr>
+          <a:xfrm>
+            <a:off x="1517903" y="2944368"/>
+            <a:ext cx="713232" cy="237744"/>
+          </a:xfrm>
+          <a:prstGeom prst="rect">
+            <a:avLst/>
+          </a:prstGeom>
+          <a:solidFill>
+            <a:srgbClr val="FFFFFF"/>
+          </a:solidFill>
+          <a:ln>
+            <a:noFill/>
+          </a:ln>
+        </p:spPr>
+        <p:style>
+          <a:lnRef idx="1">
+            <a:schemeClr val="accent1"/>
+          </a:lnRef>
+          <a:fillRef idx="3">
+            <a:schemeClr val="accent1"/>
+          </a:fillRef>
+          <a:effectRef idx="2">
+            <a:schemeClr val="accent1"/>
+          </a:effectRef>
+          <a:fontRef idx="minor">
+            <a:schemeClr val="lt1"/>
+          </a:fontRef>
+        </p:style>
+        <p:txBody>
+          <a:bodyPr rtlCol="0" anchor="ctr"/>
+          <a:lstStyle/>
+          <a:p>
+            <a:pPr algn="ctr"/>
+          </a:p>
+        </p:txBody>
+      </p:sp>
+      <p:sp>
+        <p:nvSpPr>
+          <p:cNvPr id="38" name="TextBox 37"/>
           <p:cNvSpPr txBox="1"/>
           <p:nvPr/>
         </p:nvSpPr>
         <p:spPr>
           <a:xfrm>
-            <a:off x="8915400" y="3323844"/>
-            <a:ext cx="1828800" cy="274320"/>
+            <a:off x="1517903" y="2944368"/>
+            <a:ext cx="713232" cy="237744"/>
           </a:xfrm>
           <a:prstGeom prst="rect">
             <a:avLst/>
@@ -5672,6 +5644,304 @@
                 </a:solidFill>
                 <a:latin typeface="Helvetica Neue"/>
               </a:rPr>
+              <a:t>POC DATA</a:t>
+            </a:r>
+          </a:p>
+        </p:txBody>
+      </p:sp>
+      <p:cxnSp>
+        <p:nvCxnSpPr>
+          <p:cNvPr id="39" name="Connector 38"/>
+          <p:cNvCxnSpPr/>
+          <p:nvPr/>
+        </p:nvCxnSpPr>
+        <p:spPr>
+          <a:xfrm>
+            <a:off x="1572768" y="4297680"/>
+            <a:ext cx="301751" cy="0"/>
+          </a:xfrm>
+          <a:prstGeom prst="line">
+            <a:avLst/>
+          </a:prstGeom>
+          <a:ln w="12700">
+            <a:solidFill>
+              <a:srgbClr val="B4B7BD"/>
+            </a:solidFill>
+          </a:ln>
+        </p:spPr>
+        <p:style>
+          <a:lnRef idx="2">
+            <a:schemeClr val="accent1"/>
+          </a:lnRef>
+          <a:fillRef idx="0">
+            <a:schemeClr val="accent1"/>
+          </a:fillRef>
+          <a:effectRef idx="1">
+            <a:schemeClr val="accent1"/>
+          </a:effectRef>
+          <a:fontRef idx="minor">
+            <a:schemeClr val="tx1"/>
+          </a:fontRef>
+        </p:style>
+      </p:cxnSp>
+      <p:cxnSp>
+        <p:nvCxnSpPr>
+          <p:cNvPr id="40" name="Connector 39"/>
+          <p:cNvCxnSpPr/>
+          <p:nvPr/>
+        </p:nvCxnSpPr>
+        <p:spPr>
+          <a:xfrm>
+            <a:off x="1874519" y="4297680"/>
+            <a:ext cx="0" cy="822960"/>
+          </a:xfrm>
+          <a:prstGeom prst="line">
+            <a:avLst/>
+          </a:prstGeom>
+          <a:ln w="12700">
+            <a:solidFill>
+              <a:srgbClr val="B4B7BD"/>
+            </a:solidFill>
+          </a:ln>
+        </p:spPr>
+        <p:style>
+          <a:lnRef idx="2">
+            <a:schemeClr val="accent1"/>
+          </a:lnRef>
+          <a:fillRef idx="0">
+            <a:schemeClr val="accent1"/>
+          </a:fillRef>
+          <a:effectRef idx="1">
+            <a:schemeClr val="accent1"/>
+          </a:effectRef>
+          <a:fontRef idx="minor">
+            <a:schemeClr val="tx1"/>
+          </a:fontRef>
+        </p:style>
+      </p:cxnSp>
+      <p:cxnSp>
+        <p:nvCxnSpPr>
+          <p:cNvPr id="41" name="Connector 40"/>
+          <p:cNvCxnSpPr/>
+          <p:nvPr/>
+        </p:nvCxnSpPr>
+        <p:spPr>
+          <a:xfrm>
+            <a:off x="1874519" y="5120640"/>
+            <a:ext cx="274321" cy="0"/>
+          </a:xfrm>
+          <a:prstGeom prst="line">
+            <a:avLst/>
+          </a:prstGeom>
+          <a:ln w="12700">
+            <a:solidFill>
+              <a:srgbClr val="B4B7BD"/>
+            </a:solidFill>
+            <a:tailEnd type="triangle" w="sm" len="sm"/>
+          </a:ln>
+        </p:spPr>
+        <p:style>
+          <a:lnRef idx="2">
+            <a:schemeClr val="accent1"/>
+          </a:lnRef>
+          <a:fillRef idx="0">
+            <a:schemeClr val="accent1"/>
+          </a:fillRef>
+          <a:effectRef idx="1">
+            <a:schemeClr val="accent1"/>
+          </a:effectRef>
+          <a:fontRef idx="minor">
+            <a:schemeClr val="tx1"/>
+          </a:fontRef>
+        </p:style>
+      </p:cxnSp>
+      <p:sp>
+        <p:nvSpPr>
+          <p:cNvPr id="42" name="Rectangle 41"/>
+          <p:cNvSpPr/>
+          <p:nvPr/>
+        </p:nvSpPr>
+        <p:spPr>
+          <a:xfrm>
+            <a:off x="1415034" y="4498848"/>
+            <a:ext cx="918971" cy="237744"/>
+          </a:xfrm>
+          <a:prstGeom prst="rect">
+            <a:avLst/>
+          </a:prstGeom>
+          <a:solidFill>
+            <a:srgbClr val="FFFFFF"/>
+          </a:solidFill>
+          <a:ln>
+            <a:noFill/>
+          </a:ln>
+        </p:spPr>
+        <p:style>
+          <a:lnRef idx="1">
+            <a:schemeClr val="accent1"/>
+          </a:lnRef>
+          <a:fillRef idx="3">
+            <a:schemeClr val="accent1"/>
+          </a:fillRef>
+          <a:effectRef idx="2">
+            <a:schemeClr val="accent1"/>
+          </a:effectRef>
+          <a:fontRef idx="minor">
+            <a:schemeClr val="lt1"/>
+          </a:fontRef>
+        </p:style>
+        <p:txBody>
+          <a:bodyPr rtlCol="0" anchor="ctr"/>
+          <a:lstStyle/>
+          <a:p>
+            <a:pPr algn="ctr"/>
+          </a:p>
+        </p:txBody>
+      </p:sp>
+      <p:sp>
+        <p:nvSpPr>
+          <p:cNvPr id="43" name="TextBox 42"/>
+          <p:cNvSpPr txBox="1"/>
+          <p:nvPr/>
+        </p:nvSpPr>
+        <p:spPr>
+          <a:xfrm>
+            <a:off x="1415034" y="4498848"/>
+            <a:ext cx="918971" cy="237744"/>
+          </a:xfrm>
+          <a:prstGeom prst="rect">
+            <a:avLst/>
+          </a:prstGeom>
+          <a:noFill/>
+        </p:spPr>
+        <p:txBody>
+          <a:bodyPr wrap="none" anchor="ctr">
+            <a:spAutoFit/>
+          </a:bodyPr>
+          <a:lstStyle/>
+          <a:p>
+            <a:pPr algn="ctr"/>
+            <a:r>
+              <a:rPr sz="900" b="1" spc="170">
+                <a:solidFill>
+                  <a:srgbClr val="6E6E73"/>
+                </a:solidFill>
+                <a:latin typeface="Helvetica Neue"/>
+              </a:rPr>
+              <a:t>BATCH FETCH</a:t>
+            </a:r>
+          </a:p>
+        </p:txBody>
+      </p:sp>
+      <p:cxnSp>
+        <p:nvCxnSpPr>
+          <p:cNvPr id="44" name="Connector 43"/>
+          <p:cNvCxnSpPr/>
+          <p:nvPr/>
+        </p:nvCxnSpPr>
+        <p:spPr>
+          <a:xfrm>
+            <a:off x="9875520" y="3017520"/>
+            <a:ext cx="0" cy="1024128"/>
+          </a:xfrm>
+          <a:prstGeom prst="line">
+            <a:avLst/>
+          </a:prstGeom>
+          <a:ln w="12700">
+            <a:solidFill>
+              <a:srgbClr val="B4B7BD"/>
+            </a:solidFill>
+            <a:tailEnd type="triangle" w="sm" len="sm"/>
+          </a:ln>
+        </p:spPr>
+        <p:style>
+          <a:lnRef idx="2">
+            <a:schemeClr val="accent1"/>
+          </a:lnRef>
+          <a:fillRef idx="0">
+            <a:schemeClr val="accent1"/>
+          </a:fillRef>
+          <a:effectRef idx="1">
+            <a:schemeClr val="accent1"/>
+          </a:effectRef>
+          <a:fontRef idx="minor">
+            <a:schemeClr val="tx1"/>
+          </a:fontRef>
+        </p:style>
+      </p:cxnSp>
+      <p:sp>
+        <p:nvSpPr>
+          <p:cNvPr id="45" name="Rectangle 44"/>
+          <p:cNvSpPr/>
+          <p:nvPr/>
+        </p:nvSpPr>
+        <p:spPr>
+          <a:xfrm>
+            <a:off x="9587484" y="3447288"/>
+            <a:ext cx="576071" cy="237744"/>
+          </a:xfrm>
+          <a:prstGeom prst="rect">
+            <a:avLst/>
+          </a:prstGeom>
+          <a:solidFill>
+            <a:srgbClr val="FFFFFF"/>
+          </a:solidFill>
+          <a:ln>
+            <a:noFill/>
+          </a:ln>
+        </p:spPr>
+        <p:style>
+          <a:lnRef idx="1">
+            <a:schemeClr val="accent1"/>
+          </a:lnRef>
+          <a:fillRef idx="3">
+            <a:schemeClr val="accent1"/>
+          </a:fillRef>
+          <a:effectRef idx="2">
+            <a:schemeClr val="accent1"/>
+          </a:effectRef>
+          <a:fontRef idx="minor">
+            <a:schemeClr val="lt1"/>
+          </a:fontRef>
+        </p:style>
+        <p:txBody>
+          <a:bodyPr rtlCol="0" anchor="ctr"/>
+          <a:lstStyle/>
+          <a:p>
+            <a:pPr algn="ctr"/>
+          </a:p>
+        </p:txBody>
+      </p:sp>
+      <p:sp>
+        <p:nvSpPr>
+          <p:cNvPr id="46" name="TextBox 45"/>
+          <p:cNvSpPr txBox="1"/>
+          <p:nvPr/>
+        </p:nvSpPr>
+        <p:spPr>
+          <a:xfrm>
+            <a:off x="9587484" y="3447288"/>
+            <a:ext cx="576071" cy="237744"/>
+          </a:xfrm>
+          <a:prstGeom prst="rect">
+            <a:avLst/>
+          </a:prstGeom>
+          <a:noFill/>
+        </p:spPr>
+        <p:txBody>
+          <a:bodyPr wrap="none" anchor="ctr">
+            <a:spAutoFit/>
+          </a:bodyPr>
+          <a:lstStyle/>
+          <a:p>
+            <a:pPr algn="ctr"/>
+            <a:r>
+              <a:rPr sz="900" b="1" spc="170">
+                <a:solidFill>
+                  <a:srgbClr val="6E6E73"/>
+                </a:solidFill>
+                <a:latin typeface="Helvetica Neue"/>
+              </a:rPr>
               <a:t>DEPLOY</a:t>
             </a:r>
           </a:p>
@@ -5679,7 +5949,7 @@
       </p:sp>
       <p:sp>
         <p:nvSpPr>
-          <p:cNvPr id="40" name="TextBox 39"/>
+          <p:cNvPr id="47" name="TextBox 46"/>
           <p:cNvSpPr txBox="1"/>
           <p:nvPr/>
         </p:nvSpPr>
@@ -5711,7 +5981,7 @@
                 </a:solidFill>
                 <a:latin typeface="Helvetica Neue"/>
               </a:rPr>
-              <a:t>9d · Architecture — swim-lane</a:t>
+              <a:t>9d · Architecture — swim-lane (native, editable)</a:t>
             </a:r>
           </a:p>
         </p:txBody>
@@ -5734,16 +6004,40 @@
         <p:nvPr/>
       </p:nvGrpSpPr>
       <p:grpSpPr/>
-      <p:sp>
-        <p:nvSpPr>
-          <p:cNvPr id="2" name="TextBox 1"/>
+      <p:pic>
+        <p:nvPicPr>
+          <p:cNvPr id="2" name="Picture 1" descr="image.png"/>
+          <p:cNvPicPr>
+            <a:picLocks noChangeAspect="1"/>
+          </p:cNvPicPr>
+          <p:nvPr/>
+        </p:nvPicPr>
+        <p:blipFill>
+          <a:blip r:embed="rId2"/>
+          <a:stretch>
+            <a:fillRect/>
+          </a:stretch>
+        </p:blipFill>
+        <p:spPr>
+          <a:xfrm>
+            <a:off x="0" y="0"/>
+            <a:ext cx="12191695" cy="6858000"/>
+          </a:xfrm>
+          <a:prstGeom prst="rect">
+            <a:avLst/>
+          </a:prstGeom>
+        </p:spPr>
+      </p:pic>
+      <p:sp>
+        <p:nvSpPr>
+          <p:cNvPr id="3" name="TextBox 2"/>
           <p:cNvSpPr txBox="1"/>
           <p:nvPr/>
         </p:nvSpPr>
         <p:spPr>
           <a:xfrm>
-            <a:off x="822960" y="822960"/>
-            <a:ext cx="5486400" cy="365760"/>
+            <a:off x="365760" y="6446520"/>
+            <a:ext cx="5486400" cy="320040"/>
           </a:xfrm>
           <a:prstGeom prst="rect">
             <a:avLst/>
@@ -5762,225 +6056,13 @@
               </a:lnSpc>
             </a:pPr>
             <a:r>
-              <a:rPr sz="1200" b="1" spc="170">
-                <a:solidFill>
-                  <a:srgbClr val="1D4ED8"/>
-                </a:solidFill>
-                <a:latin typeface="Helvetica Neue"/>
-              </a:rPr>
-              <a:t>VISUAL</a:t>
-            </a:r>
-          </a:p>
-        </p:txBody>
-      </p:sp>
-      <p:sp>
-        <p:nvSpPr>
-          <p:cNvPr id="3" name="TextBox 2"/>
-          <p:cNvSpPr txBox="1"/>
-          <p:nvPr/>
-        </p:nvSpPr>
-        <p:spPr>
-          <a:xfrm>
-            <a:off x="786384" y="1234440"/>
-            <a:ext cx="5486400" cy="1463040"/>
-          </a:xfrm>
-          <a:prstGeom prst="rect">
-            <a:avLst/>
-          </a:prstGeom>
-          <a:noFill/>
-        </p:spPr>
-        <p:txBody>
-          <a:bodyPr wrap="square">
-            <a:spAutoFit/>
-          </a:bodyPr>
-          <a:lstStyle/>
-          <a:p>
-            <a:pPr algn="l">
-              <a:lnSpc>
-                <a:spcPct val="112000"/>
-              </a:lnSpc>
-            </a:pPr>
-            <a:r>
-              <a:rPr sz="3400" b="1" spc="-40">
-                <a:solidFill>
-                  <a:srgbClr val="1D1D1F"/>
-                </a:solidFill>
-                <a:latin typeface="Helvetica Neue"/>
-              </a:rPr>
-              <a:t>Image + caption</a:t>
-            </a:r>
-          </a:p>
-        </p:txBody>
-      </p:sp>
-      <p:sp>
-        <p:nvSpPr>
-          <p:cNvPr id="4" name="Rounded Rectangle 3"/>
-          <p:cNvSpPr/>
-          <p:nvPr/>
-        </p:nvSpPr>
-        <p:spPr>
-          <a:xfrm>
-            <a:off x="6217920" y="1188720"/>
-            <a:ext cx="5120640" cy="4206240"/>
-          </a:xfrm>
-          <a:prstGeom prst="roundRect">
-            <a:avLst>
-              <a:gd name="adj" fmla="val 3000"/>
-            </a:avLst>
-          </a:prstGeom>
-          <a:solidFill>
-            <a:srgbClr val="F5F5F7"/>
-          </a:solidFill>
-          <a:ln w="19050">
-            <a:solidFill>
-              <a:srgbClr val="D2D2D7"/>
-            </a:solidFill>
-          </a:ln>
-        </p:spPr>
-        <p:style>
-          <a:lnRef idx="1">
-            <a:schemeClr val="accent1"/>
-          </a:lnRef>
-          <a:fillRef idx="3">
-            <a:schemeClr val="accent1"/>
-          </a:fillRef>
-          <a:effectRef idx="2">
-            <a:schemeClr val="accent1"/>
-          </a:effectRef>
-          <a:fontRef idx="minor">
-            <a:schemeClr val="lt1"/>
-          </a:fontRef>
-        </p:style>
-        <p:txBody>
-          <a:bodyPr rtlCol="0" anchor="ctr"/>
-          <a:lstStyle/>
-          <a:p>
-            <a:pPr algn="ctr"/>
-            <a:r>
-              <a:rPr sz="1400">
+              <a:rPr sz="900" b="0">
                 <a:solidFill>
                   <a:srgbClr val="AEAEB2"/>
                 </a:solidFill>
                 <a:latin typeface="Helvetica Neue"/>
               </a:rPr>
-              <a:t>[ image ]</a:t>
-            </a:r>
-          </a:p>
-        </p:txBody>
-      </p:sp>
-      <p:sp>
-        <p:nvSpPr>
-          <p:cNvPr id="5" name="TextBox 4"/>
-          <p:cNvSpPr txBox="1"/>
-          <p:nvPr/>
-        </p:nvSpPr>
-        <p:spPr>
-          <a:xfrm>
-            <a:off x="822960" y="2468880"/>
-            <a:ext cx="4937760" cy="3200400"/>
-          </a:xfrm>
-          <a:prstGeom prst="rect">
-            <a:avLst/>
-          </a:prstGeom>
-          <a:noFill/>
-        </p:spPr>
-        <p:txBody>
-          <a:bodyPr wrap="square">
-            <a:spAutoFit/>
-          </a:bodyPr>
-          <a:lstStyle/>
-          <a:p>
-            <a:pPr algn="l">
-              <a:lnSpc>
-                <a:spcPct val="130000"/>
-              </a:lnSpc>
-            </a:pPr>
-            <a:r>
-              <a:rPr sz="1800" b="0">
-                <a:solidFill>
-                  <a:srgbClr val="424245"/>
-                </a:solidFill>
-                <a:latin typeface="Helvetica Neue"/>
-              </a:rPr>
-              <a:t>Body sits left; image fills the right half.</a:t>
-            </a:r>
-          </a:p>
-        </p:txBody>
-      </p:sp>
-      <p:sp>
-        <p:nvSpPr>
-          <p:cNvPr id="6" name="TextBox 5"/>
-          <p:cNvSpPr txBox="1"/>
-          <p:nvPr/>
-        </p:nvSpPr>
-        <p:spPr>
-          <a:xfrm>
-            <a:off x="6217920" y="5486400"/>
-            <a:ext cx="5120640" cy="365760"/>
-          </a:xfrm>
-          <a:prstGeom prst="rect">
-            <a:avLst/>
-          </a:prstGeom>
-          <a:noFill/>
-        </p:spPr>
-        <p:txBody>
-          <a:bodyPr wrap="square">
-            <a:spAutoFit/>
-          </a:bodyPr>
-          <a:lstStyle/>
-          <a:p>
-            <a:pPr algn="l">
-              <a:lnSpc>
-                <a:spcPct val="112000"/>
-              </a:lnSpc>
-            </a:pPr>
-            <a:r>
-              <a:rPr sz="1300" b="0">
-                <a:solidFill>
-                  <a:srgbClr val="6E6E73"/>
-                </a:solidFill>
-                <a:latin typeface="Helvetica Neue"/>
-              </a:rPr>
-              <a:t>Figure 1 — caption in Slate</a:t>
-            </a:r>
-          </a:p>
-        </p:txBody>
-      </p:sp>
-      <p:sp>
-        <p:nvSpPr>
-          <p:cNvPr id="7" name="TextBox 6"/>
-          <p:cNvSpPr txBox="1"/>
-          <p:nvPr/>
-        </p:nvSpPr>
-        <p:spPr>
-          <a:xfrm>
-            <a:off x="365760" y="6446520"/>
-            <a:ext cx="5486400" cy="320040"/>
-          </a:xfrm>
-          <a:prstGeom prst="rect">
-            <a:avLst/>
-          </a:prstGeom>
-          <a:noFill/>
-        </p:spPr>
-        <p:txBody>
-          <a:bodyPr wrap="square">
-            <a:spAutoFit/>
-          </a:bodyPr>
-          <a:lstStyle/>
-          <a:p>
-            <a:pPr algn="l">
-              <a:lnSpc>
-                <a:spcPct val="112000"/>
-              </a:lnSpc>
-            </a:pPr>
-            <a:r>
-              <a:rPr sz="900" b="0">
-                <a:solidFill>
-                  <a:srgbClr val="AEAEB2"/>
-                </a:solidFill>
-                <a:latin typeface="Helvetica Neue"/>
-              </a:rPr>
-              <a:t>10 · Image + caption</a:t>
+              <a:t>9e · Architecture — swim-lane (SVG, publication-grade)</a:t>
             </a:r>
           </a:p>
         </p:txBody>
@@ -6011,86 +6093,8 @@
         </p:nvSpPr>
         <p:spPr>
           <a:xfrm>
-            <a:off x="1097280" y="2194560"/>
-            <a:ext cx="10058400" cy="1828800"/>
-          </a:xfrm>
-          <a:prstGeom prst="rect">
-            <a:avLst/>
-          </a:prstGeom>
-          <a:noFill/>
-        </p:spPr>
-        <p:txBody>
-          <a:bodyPr wrap="square">
-            <a:spAutoFit/>
-          </a:bodyPr>
-          <a:lstStyle/>
-          <a:p>
-            <a:pPr algn="ctr">
-              <a:lnSpc>
-                <a:spcPct val="120000"/>
-              </a:lnSpc>
-            </a:pPr>
-            <a:r>
-              <a:rPr sz="3600" b="1" spc="-40">
-                <a:solidFill>
-                  <a:srgbClr val="1D1D1F"/>
-                </a:solidFill>
-                <a:latin typeface="Helvetica Neue"/>
-              </a:rPr>
-              <a:t>“Good design is as little design as possible.”</a:t>
-            </a:r>
-          </a:p>
-        </p:txBody>
-      </p:sp>
-      <p:sp>
-        <p:nvSpPr>
-          <p:cNvPr id="3" name="TextBox 2"/>
-          <p:cNvSpPr txBox="1"/>
-          <p:nvPr/>
-        </p:nvSpPr>
-        <p:spPr>
-          <a:xfrm>
-            <a:off x="1097280" y="4023360"/>
-            <a:ext cx="10058400" cy="457200"/>
-          </a:xfrm>
-          <a:prstGeom prst="rect">
-            <a:avLst/>
-          </a:prstGeom>
-          <a:noFill/>
-        </p:spPr>
-        <p:txBody>
-          <a:bodyPr wrap="square">
-            <a:spAutoFit/>
-          </a:bodyPr>
-          <a:lstStyle/>
-          <a:p>
-            <a:pPr algn="ctr">
-              <a:lnSpc>
-                <a:spcPct val="112000"/>
-              </a:lnSpc>
-            </a:pPr>
-            <a:r>
-              <a:rPr sz="1600" b="0">
-                <a:solidFill>
-                  <a:srgbClr val="6E6E73"/>
-                </a:solidFill>
-                <a:latin typeface="Helvetica Neue"/>
-              </a:rPr>
-              <a:t>— Dieter Rams</a:t>
-            </a:r>
-          </a:p>
-        </p:txBody>
-      </p:sp>
-      <p:sp>
-        <p:nvSpPr>
-          <p:cNvPr id="4" name="TextBox 3"/>
-          <p:cNvSpPr txBox="1"/>
-          <p:nvPr/>
-        </p:nvSpPr>
-        <p:spPr>
-          <a:xfrm>
-            <a:off x="365760" y="6446520"/>
-            <a:ext cx="5486400" cy="320040"/>
+            <a:off x="822960" y="822960"/>
+            <a:ext cx="5486400" cy="365760"/>
           </a:xfrm>
           <a:prstGeom prst="rect">
             <a:avLst/>
@@ -6109,13 +6113,225 @@
               </a:lnSpc>
             </a:pPr>
             <a:r>
+              <a:rPr sz="1200" b="1" spc="170">
+                <a:solidFill>
+                  <a:srgbClr val="1D4ED8"/>
+                </a:solidFill>
+                <a:latin typeface="Helvetica Neue"/>
+              </a:rPr>
+              <a:t>VISUAL</a:t>
+            </a:r>
+          </a:p>
+        </p:txBody>
+      </p:sp>
+      <p:sp>
+        <p:nvSpPr>
+          <p:cNvPr id="3" name="TextBox 2"/>
+          <p:cNvSpPr txBox="1"/>
+          <p:nvPr/>
+        </p:nvSpPr>
+        <p:spPr>
+          <a:xfrm>
+            <a:off x="786384" y="1234440"/>
+            <a:ext cx="5486400" cy="1463040"/>
+          </a:xfrm>
+          <a:prstGeom prst="rect">
+            <a:avLst/>
+          </a:prstGeom>
+          <a:noFill/>
+        </p:spPr>
+        <p:txBody>
+          <a:bodyPr wrap="square">
+            <a:spAutoFit/>
+          </a:bodyPr>
+          <a:lstStyle/>
+          <a:p>
+            <a:pPr algn="l">
+              <a:lnSpc>
+                <a:spcPct val="112000"/>
+              </a:lnSpc>
+            </a:pPr>
+            <a:r>
+              <a:rPr sz="3400" b="1" spc="-40">
+                <a:solidFill>
+                  <a:srgbClr val="1D1D1F"/>
+                </a:solidFill>
+                <a:latin typeface="Helvetica Neue"/>
+              </a:rPr>
+              <a:t>Image + caption</a:t>
+            </a:r>
+          </a:p>
+        </p:txBody>
+      </p:sp>
+      <p:sp>
+        <p:nvSpPr>
+          <p:cNvPr id="4" name="Rounded Rectangle 3"/>
+          <p:cNvSpPr/>
+          <p:nvPr/>
+        </p:nvSpPr>
+        <p:spPr>
+          <a:xfrm>
+            <a:off x="6217920" y="1188720"/>
+            <a:ext cx="5120640" cy="4206240"/>
+          </a:xfrm>
+          <a:prstGeom prst="roundRect">
+            <a:avLst>
+              <a:gd name="adj" fmla="val 3000"/>
+            </a:avLst>
+          </a:prstGeom>
+          <a:solidFill>
+            <a:srgbClr val="F5F5F7"/>
+          </a:solidFill>
+          <a:ln w="19050">
+            <a:solidFill>
+              <a:srgbClr val="D2D2D7"/>
+            </a:solidFill>
+          </a:ln>
+        </p:spPr>
+        <p:style>
+          <a:lnRef idx="1">
+            <a:schemeClr val="accent1"/>
+          </a:lnRef>
+          <a:fillRef idx="3">
+            <a:schemeClr val="accent1"/>
+          </a:fillRef>
+          <a:effectRef idx="2">
+            <a:schemeClr val="accent1"/>
+          </a:effectRef>
+          <a:fontRef idx="minor">
+            <a:schemeClr val="lt1"/>
+          </a:fontRef>
+        </p:style>
+        <p:txBody>
+          <a:bodyPr rtlCol="0" anchor="ctr"/>
+          <a:lstStyle/>
+          <a:p>
+            <a:pPr algn="ctr"/>
+            <a:r>
+              <a:rPr sz="1400">
+                <a:solidFill>
+                  <a:srgbClr val="AEAEB2"/>
+                </a:solidFill>
+                <a:latin typeface="Helvetica Neue"/>
+              </a:rPr>
+              <a:t>[ image ]</a:t>
+            </a:r>
+          </a:p>
+        </p:txBody>
+      </p:sp>
+      <p:sp>
+        <p:nvSpPr>
+          <p:cNvPr id="5" name="TextBox 4"/>
+          <p:cNvSpPr txBox="1"/>
+          <p:nvPr/>
+        </p:nvSpPr>
+        <p:spPr>
+          <a:xfrm>
+            <a:off x="822960" y="2468880"/>
+            <a:ext cx="4937760" cy="3200400"/>
+          </a:xfrm>
+          <a:prstGeom prst="rect">
+            <a:avLst/>
+          </a:prstGeom>
+          <a:noFill/>
+        </p:spPr>
+        <p:txBody>
+          <a:bodyPr wrap="square">
+            <a:spAutoFit/>
+          </a:bodyPr>
+          <a:lstStyle/>
+          <a:p>
+            <a:pPr algn="l">
+              <a:lnSpc>
+                <a:spcPct val="130000"/>
+              </a:lnSpc>
+            </a:pPr>
+            <a:r>
+              <a:rPr sz="1800" b="0">
+                <a:solidFill>
+                  <a:srgbClr val="424245"/>
+                </a:solidFill>
+                <a:latin typeface="Helvetica Neue"/>
+              </a:rPr>
+              <a:t>Body sits left; image fills the right half.</a:t>
+            </a:r>
+          </a:p>
+        </p:txBody>
+      </p:sp>
+      <p:sp>
+        <p:nvSpPr>
+          <p:cNvPr id="6" name="TextBox 5"/>
+          <p:cNvSpPr txBox="1"/>
+          <p:nvPr/>
+        </p:nvSpPr>
+        <p:spPr>
+          <a:xfrm>
+            <a:off x="6217920" y="5486400"/>
+            <a:ext cx="5120640" cy="365760"/>
+          </a:xfrm>
+          <a:prstGeom prst="rect">
+            <a:avLst/>
+          </a:prstGeom>
+          <a:noFill/>
+        </p:spPr>
+        <p:txBody>
+          <a:bodyPr wrap="square">
+            <a:spAutoFit/>
+          </a:bodyPr>
+          <a:lstStyle/>
+          <a:p>
+            <a:pPr algn="l">
+              <a:lnSpc>
+                <a:spcPct val="112000"/>
+              </a:lnSpc>
+            </a:pPr>
+            <a:r>
+              <a:rPr sz="1300" b="0">
+                <a:solidFill>
+                  <a:srgbClr val="6E6E73"/>
+                </a:solidFill>
+                <a:latin typeface="Helvetica Neue"/>
+              </a:rPr>
+              <a:t>Figure 1 — caption in Slate</a:t>
+            </a:r>
+          </a:p>
+        </p:txBody>
+      </p:sp>
+      <p:sp>
+        <p:nvSpPr>
+          <p:cNvPr id="7" name="TextBox 6"/>
+          <p:cNvSpPr txBox="1"/>
+          <p:nvPr/>
+        </p:nvSpPr>
+        <p:spPr>
+          <a:xfrm>
+            <a:off x="365760" y="6446520"/>
+            <a:ext cx="5486400" cy="320040"/>
+          </a:xfrm>
+          <a:prstGeom prst="rect">
+            <a:avLst/>
+          </a:prstGeom>
+          <a:noFill/>
+        </p:spPr>
+        <p:txBody>
+          <a:bodyPr wrap="square">
+            <a:spAutoFit/>
+          </a:bodyPr>
+          <a:lstStyle/>
+          <a:p>
+            <a:pPr algn="l">
+              <a:lnSpc>
+                <a:spcPct val="112000"/>
+              </a:lnSpc>
+            </a:pPr>
+            <a:r>
               <a:rPr sz="900" b="0">
                 <a:solidFill>
                   <a:srgbClr val="AEAEB2"/>
                 </a:solidFill>
                 <a:latin typeface="Helvetica Neue"/>
               </a:rPr>
-              <a:t>11 · Quote</a:t>
+              <a:t>10 · Image + caption</a:t>
             </a:r>
           </a:p>
         </p:txBody>
@@ -6129,6 +6345,141 @@
 </file>
 
 <file path=ppt/slides/slide15.xml><?xml version="1.0" encoding="utf-8"?>
+<p:sld xmlns:a="http://schemas.openxmlformats.org/drawingml/2006/main" xmlns:p="http://schemas.openxmlformats.org/presentationml/2006/main" xmlns:r="http://schemas.openxmlformats.org/officeDocument/2006/relationships">
+  <p:cSld>
+    <p:spTree>
+      <p:nvGrpSpPr>
+        <p:cNvPr id="1" name=""/>
+        <p:cNvGrpSpPr/>
+        <p:nvPr/>
+      </p:nvGrpSpPr>
+      <p:grpSpPr/>
+      <p:sp>
+        <p:nvSpPr>
+          <p:cNvPr id="2" name="TextBox 1"/>
+          <p:cNvSpPr txBox="1"/>
+          <p:nvPr/>
+        </p:nvSpPr>
+        <p:spPr>
+          <a:xfrm>
+            <a:off x="1097280" y="2194560"/>
+            <a:ext cx="10058400" cy="1828800"/>
+          </a:xfrm>
+          <a:prstGeom prst="rect">
+            <a:avLst/>
+          </a:prstGeom>
+          <a:noFill/>
+        </p:spPr>
+        <p:txBody>
+          <a:bodyPr wrap="square">
+            <a:spAutoFit/>
+          </a:bodyPr>
+          <a:lstStyle/>
+          <a:p>
+            <a:pPr algn="ctr">
+              <a:lnSpc>
+                <a:spcPct val="120000"/>
+              </a:lnSpc>
+            </a:pPr>
+            <a:r>
+              <a:rPr sz="3600" b="1" spc="-40">
+                <a:solidFill>
+                  <a:srgbClr val="1D1D1F"/>
+                </a:solidFill>
+                <a:latin typeface="Helvetica Neue"/>
+              </a:rPr>
+              <a:t>“Good design is as little design as possible.”</a:t>
+            </a:r>
+          </a:p>
+        </p:txBody>
+      </p:sp>
+      <p:sp>
+        <p:nvSpPr>
+          <p:cNvPr id="3" name="TextBox 2"/>
+          <p:cNvSpPr txBox="1"/>
+          <p:nvPr/>
+        </p:nvSpPr>
+        <p:spPr>
+          <a:xfrm>
+            <a:off x="1097280" y="4023360"/>
+            <a:ext cx="10058400" cy="457200"/>
+          </a:xfrm>
+          <a:prstGeom prst="rect">
+            <a:avLst/>
+          </a:prstGeom>
+          <a:noFill/>
+        </p:spPr>
+        <p:txBody>
+          <a:bodyPr wrap="square">
+            <a:spAutoFit/>
+          </a:bodyPr>
+          <a:lstStyle/>
+          <a:p>
+            <a:pPr algn="ctr">
+              <a:lnSpc>
+                <a:spcPct val="112000"/>
+              </a:lnSpc>
+            </a:pPr>
+            <a:r>
+              <a:rPr sz="1600" b="0">
+                <a:solidFill>
+                  <a:srgbClr val="6E6E73"/>
+                </a:solidFill>
+                <a:latin typeface="Helvetica Neue"/>
+              </a:rPr>
+              <a:t>— Dieter Rams</a:t>
+            </a:r>
+          </a:p>
+        </p:txBody>
+      </p:sp>
+      <p:sp>
+        <p:nvSpPr>
+          <p:cNvPr id="4" name="TextBox 3"/>
+          <p:cNvSpPr txBox="1"/>
+          <p:nvPr/>
+        </p:nvSpPr>
+        <p:spPr>
+          <a:xfrm>
+            <a:off x="365760" y="6446520"/>
+            <a:ext cx="5486400" cy="320040"/>
+          </a:xfrm>
+          <a:prstGeom prst="rect">
+            <a:avLst/>
+          </a:prstGeom>
+          <a:noFill/>
+        </p:spPr>
+        <p:txBody>
+          <a:bodyPr wrap="square">
+            <a:spAutoFit/>
+          </a:bodyPr>
+          <a:lstStyle/>
+          <a:p>
+            <a:pPr algn="l">
+              <a:lnSpc>
+                <a:spcPct val="112000"/>
+              </a:lnSpc>
+            </a:pPr>
+            <a:r>
+              <a:rPr sz="900" b="0">
+                <a:solidFill>
+                  <a:srgbClr val="AEAEB2"/>
+                </a:solidFill>
+                <a:latin typeface="Helvetica Neue"/>
+              </a:rPr>
+              <a:t>11 · Quote</a:t>
+            </a:r>
+          </a:p>
+        </p:txBody>
+      </p:sp>
+    </p:spTree>
+  </p:cSld>
+  <p:clrMapOvr>
+    <a:masterClrMapping/>
+  </p:clrMapOvr>
+</p:sld>
+</file>
+
+<file path=ppt/slides/slide16.xml><?xml version="1.0" encoding="utf-8"?>
 <p:sld xmlns:a="http://schemas.openxmlformats.org/drawingml/2006/main" xmlns:p="http://schemas.openxmlformats.org/presentationml/2006/main" xmlns:r="http://schemas.openxmlformats.org/officeDocument/2006/relationships">
   <p:cSld>
     <p:spTree>

</xml_diff>